<commit_message>
Remove unused document from urok11
</commit_message>
<xml_diff>
--- a/10 класс/urok1/Презентация_занятие1_финал.pptx
+++ b/10 класс/urok1/Презентация_занятие1_финал.pptx
@@ -3496,9 +3496,9 @@
               <a:buNone/>
             </a:pPr>
             <a:r>
-              <a:rPr lang="en-US" sz="1600" dirty="0">
-                <a:solidFill>
-                  <a:srgbClr val="4FD1E0"/>
+              <a:rPr lang="en-US" sz="2000" b="1" dirty="0">
+                <a:solidFill>
+                  <a:schemeClr val="bg1"/>
                 </a:solidFill>
                 <a:latin typeface="Consolas" pitchFamily="34" charset="0"/>
                 <a:ea typeface="Consolas" pitchFamily="34" charset="-122"/>
@@ -3506,7 +3506,11 @@
               </a:rPr>
               <a:t>print("Салом, дуне!")</a:t>
             </a:r>
-            <a:endParaRPr lang="en-US" sz="1600" dirty="0"/>
+            <a:endParaRPr lang="en-US" sz="2000" b="1" dirty="0">
+              <a:solidFill>
+                <a:schemeClr val="bg1"/>
+              </a:solidFill>
+            </a:endParaRPr>
           </a:p>
           <a:p>
             <a:pPr marL="0" indent="0">
@@ -3516,9 +3520,9 @@
               <a:buNone/>
             </a:pPr>
             <a:r>
-              <a:rPr lang="en-US" sz="1600" dirty="0">
-                <a:solidFill>
-                  <a:srgbClr val="4FD1E0"/>
+              <a:rPr lang="en-US" sz="2000" b="1" dirty="0">
+                <a:solidFill>
+                  <a:schemeClr val="bg1"/>
                 </a:solidFill>
                 <a:latin typeface="Consolas" pitchFamily="34" charset="0"/>
                 <a:ea typeface="Consolas" pitchFamily="34" charset="-122"/>
@@ -3526,7 +3530,11 @@
               </a:rPr>
               <a:t>print("Класс:", 10)</a:t>
             </a:r>
-            <a:endParaRPr lang="en-US" sz="1600" dirty="0"/>
+            <a:endParaRPr lang="en-US" sz="2000" b="1" dirty="0">
+              <a:solidFill>
+                <a:schemeClr val="bg1"/>
+              </a:solidFill>
+            </a:endParaRPr>
           </a:p>
           <a:p>
             <a:pPr marL="0" indent="0">
@@ -3536,9 +3544,9 @@
               <a:buNone/>
             </a:pPr>
             <a:r>
-              <a:rPr lang="en-US" sz="1600" dirty="0">
-                <a:solidFill>
-                  <a:srgbClr val="4FD1E0"/>
+              <a:rPr lang="en-US" sz="2000" b="1" dirty="0">
+                <a:solidFill>
+                  <a:schemeClr val="bg1"/>
                 </a:solidFill>
                 <a:latin typeface="Consolas" pitchFamily="34" charset="0"/>
                 <a:ea typeface="Consolas" pitchFamily="34" charset="-122"/>
@@ -3546,7 +3554,11 @@
               </a:rPr>
               <a:t>print("Информатика", "-", "первый урок")</a:t>
             </a:r>
-            <a:endParaRPr lang="en-US" sz="1600" dirty="0"/>
+            <a:endParaRPr lang="en-US" sz="2000" b="1" dirty="0">
+              <a:solidFill>
+                <a:schemeClr val="bg1"/>
+              </a:solidFill>
+            </a:endParaRPr>
           </a:p>
         </p:txBody>
       </p:sp>
@@ -3766,9 +3778,9 @@
               <a:buNone/>
             </a:pPr>
             <a:r>
-              <a:rPr lang="en-US" sz="1500" dirty="0">
-                <a:solidFill>
-                  <a:srgbClr val="4FD1E0"/>
+              <a:rPr lang="en-US" sz="2000" dirty="0">
+                <a:solidFill>
+                  <a:schemeClr val="bg1"/>
                 </a:solidFill>
                 <a:latin typeface="Consolas" pitchFamily="34" charset="0"/>
                 <a:ea typeface="Consolas" pitchFamily="34" charset="-122"/>
@@ -3776,7 +3788,11 @@
               </a:rPr>
               <a:t>Салом, дуне!</a:t>
             </a:r>
-            <a:endParaRPr lang="en-US" sz="1500" dirty="0"/>
+            <a:endParaRPr lang="en-US" sz="2000" dirty="0">
+              <a:solidFill>
+                <a:schemeClr val="bg1"/>
+              </a:solidFill>
+            </a:endParaRPr>
           </a:p>
           <a:p>
             <a:pPr marL="0" indent="0">
@@ -3786,9 +3802,9 @@
               <a:buNone/>
             </a:pPr>
             <a:r>
-              <a:rPr lang="en-US" sz="1500" dirty="0">
-                <a:solidFill>
-                  <a:srgbClr val="4FD1E0"/>
+              <a:rPr lang="en-US" sz="2000" dirty="0">
+                <a:solidFill>
+                  <a:schemeClr val="bg1"/>
                 </a:solidFill>
                 <a:latin typeface="Consolas" pitchFamily="34" charset="0"/>
                 <a:ea typeface="Consolas" pitchFamily="34" charset="-122"/>
@@ -3796,7 +3812,11 @@
               </a:rPr>
               <a:t>Класс: 10</a:t>
             </a:r>
-            <a:endParaRPr lang="en-US" sz="1500" dirty="0"/>
+            <a:endParaRPr lang="en-US" sz="2000" dirty="0">
+              <a:solidFill>
+                <a:schemeClr val="bg1"/>
+              </a:solidFill>
+            </a:endParaRPr>
           </a:p>
           <a:p>
             <a:pPr marL="0" indent="0">
@@ -3806,9 +3826,9 @@
               <a:buNone/>
             </a:pPr>
             <a:r>
-              <a:rPr lang="en-US" sz="1500" dirty="0">
-                <a:solidFill>
-                  <a:srgbClr val="4FD1E0"/>
+              <a:rPr lang="en-US" sz="2000" dirty="0">
+                <a:solidFill>
+                  <a:schemeClr val="bg1"/>
                 </a:solidFill>
                 <a:latin typeface="Consolas" pitchFamily="34" charset="0"/>
                 <a:ea typeface="Consolas" pitchFamily="34" charset="-122"/>
@@ -3816,7 +3836,11 @@
               </a:rPr>
               <a:t>Информатика - первый урок</a:t>
             </a:r>
-            <a:endParaRPr lang="en-US" sz="1500" dirty="0"/>
+            <a:endParaRPr lang="en-US" sz="2000" dirty="0">
+              <a:solidFill>
+                <a:schemeClr val="bg1"/>
+              </a:solidFill>
+            </a:endParaRPr>
           </a:p>
         </p:txBody>
       </p:sp>
@@ -3845,9 +3869,9 @@
               <a:buNone/>
             </a:pPr>
             <a:r>
-              <a:rPr lang="en-US" sz="1600" i="1" dirty="0">
-                <a:solidFill>
-                  <a:srgbClr val="A9A3C4"/>
+              <a:rPr lang="en-US" sz="2000" b="1" i="1" dirty="0">
+                <a:solidFill>
+                  <a:schemeClr val="bg1"/>
                 </a:solidFill>
                 <a:latin typeface="Calibri" pitchFamily="34" charset="0"/>
                 <a:ea typeface="Calibri" pitchFamily="34" charset="-122"/>
@@ -3855,7 +3879,11 @@
               </a:rPr>
               <a:t>Внутри одного print можно писать несколько значений через запятую — они выведутся через пробел.</a:t>
             </a:r>
-            <a:endParaRPr lang="en-US" sz="1600" dirty="0"/>
+            <a:endParaRPr lang="en-US" sz="2000" b="1" dirty="0">
+              <a:solidFill>
+                <a:schemeClr val="bg1"/>
+              </a:solidFill>
+            </a:endParaRPr>
           </a:p>
         </p:txBody>
       </p:sp>
@@ -4113,9 +4141,9 @@
               <a:buNone/>
             </a:pPr>
             <a:r>
-              <a:rPr lang="en-US" sz="1600" dirty="0">
-                <a:solidFill>
-                  <a:srgbClr val="4FD1E0"/>
+              <a:rPr lang="en-US" sz="2000" dirty="0">
+                <a:solidFill>
+                  <a:schemeClr val="bg1"/>
                 </a:solidFill>
                 <a:latin typeface="Consolas" pitchFamily="34" charset="0"/>
                 <a:ea typeface="Consolas" pitchFamily="34" charset="-122"/>
@@ -4123,7 +4151,11 @@
               </a:rPr>
               <a:t>Мой класс: 10</a:t>
             </a:r>
-            <a:endParaRPr lang="en-US" sz="1600" dirty="0"/>
+            <a:endParaRPr lang="en-US" sz="2000" dirty="0">
+              <a:solidFill>
+                <a:schemeClr val="bg1"/>
+              </a:solidFill>
+            </a:endParaRPr>
           </a:p>
         </p:txBody>
       </p:sp>
@@ -4395,7 +4427,7 @@
               <a:buNone/>
             </a:pPr>
             <a:r>
-              <a:rPr lang="en-US" sz="1600" b="1" dirty="0">
+              <a:rPr lang="en-US" sz="2000" b="1" dirty="0">
                 <a:solidFill>
                   <a:srgbClr val="FFFFFF"/>
                 </a:solidFill>
@@ -4405,7 +4437,7 @@
               </a:rPr>
               <a:t>Не закрыта кавычка</a:t>
             </a:r>
-            <a:endParaRPr lang="en-US" sz="1600" dirty="0"/>
+            <a:endParaRPr lang="en-US" sz="2000" dirty="0"/>
           </a:p>
         </p:txBody>
       </p:sp>
@@ -4434,9 +4466,9 @@
               <a:buNone/>
             </a:pPr>
             <a:r>
-              <a:rPr lang="en-US" sz="1300" dirty="0">
-                <a:solidFill>
-                  <a:srgbClr val="4FD1E0"/>
+              <a:rPr lang="en-US" sz="2000" dirty="0">
+                <a:solidFill>
+                  <a:schemeClr val="bg1"/>
                 </a:solidFill>
                 <a:latin typeface="Consolas" pitchFamily="34" charset="0"/>
                 <a:ea typeface="Consolas" pitchFamily="34" charset="-122"/>
@@ -4444,7 +4476,11 @@
               </a:rPr>
               <a:t>unterminated string literal</a:t>
             </a:r>
-            <a:endParaRPr lang="en-US" sz="1300" dirty="0"/>
+            <a:endParaRPr lang="en-US" sz="2000" dirty="0">
+              <a:solidFill>
+                <a:schemeClr val="bg1"/>
+              </a:solidFill>
+            </a:endParaRPr>
           </a:p>
         </p:txBody>
       </p:sp>
@@ -4473,9 +4509,9 @@
               <a:buNone/>
             </a:pPr>
             <a:r>
-              <a:rPr lang="en-US" sz="1400" dirty="0">
-                <a:solidFill>
-                  <a:srgbClr val="A9A3C4"/>
+              <a:rPr lang="en-US" dirty="0">
+                <a:solidFill>
+                  <a:schemeClr val="bg1"/>
                 </a:solidFill>
                 <a:latin typeface="Calibri" pitchFamily="34" charset="0"/>
                 <a:ea typeface="Calibri" pitchFamily="34" charset="-122"/>
@@ -4483,7 +4519,11 @@
               </a:rPr>
               <a:t>Проверь кавычки: сколько открыл — столько закрой</a:t>
             </a:r>
-            <a:endParaRPr lang="en-US" sz="1400" dirty="0"/>
+            <a:endParaRPr lang="en-US" dirty="0">
+              <a:solidFill>
+                <a:schemeClr val="bg1"/>
+              </a:solidFill>
+            </a:endParaRPr>
           </a:p>
         </p:txBody>
       </p:sp>
@@ -4539,7 +4579,7 @@
               <a:buNone/>
             </a:pPr>
             <a:r>
-              <a:rPr lang="en-US" sz="1600" b="1" dirty="0">
+              <a:rPr lang="en-US" sz="2000" b="1" dirty="0">
                 <a:solidFill>
                   <a:srgbClr val="FFFFFF"/>
                 </a:solidFill>
@@ -4549,7 +4589,7 @@
               </a:rPr>
               <a:t>Не закрыта скобка</a:t>
             </a:r>
-            <a:endParaRPr lang="en-US" sz="1600" dirty="0"/>
+            <a:endParaRPr lang="en-US" sz="2000" dirty="0"/>
           </a:p>
         </p:txBody>
       </p:sp>
@@ -4578,9 +4618,9 @@
               <a:buNone/>
             </a:pPr>
             <a:r>
-              <a:rPr lang="en-US" sz="1300" dirty="0">
-                <a:solidFill>
-                  <a:srgbClr val="4FD1E0"/>
+              <a:rPr lang="en-US" sz="2000" dirty="0">
+                <a:solidFill>
+                  <a:schemeClr val="bg1"/>
                 </a:solidFill>
                 <a:latin typeface="Consolas" pitchFamily="34" charset="0"/>
                 <a:ea typeface="Consolas" pitchFamily="34" charset="-122"/>
@@ -4588,7 +4628,11 @@
               </a:rPr>
               <a:t>'(' was never closed</a:t>
             </a:r>
-            <a:endParaRPr lang="en-US" sz="1300" dirty="0"/>
+            <a:endParaRPr lang="en-US" sz="2000" dirty="0">
+              <a:solidFill>
+                <a:schemeClr val="bg1"/>
+              </a:solidFill>
+            </a:endParaRPr>
           </a:p>
         </p:txBody>
       </p:sp>
@@ -4617,9 +4661,9 @@
               <a:buNone/>
             </a:pPr>
             <a:r>
-              <a:rPr lang="en-US" sz="1400" dirty="0">
-                <a:solidFill>
-                  <a:srgbClr val="A9A3C4"/>
+              <a:rPr lang="en-US" sz="2000" dirty="0">
+                <a:solidFill>
+                  <a:schemeClr val="bg1"/>
                 </a:solidFill>
                 <a:latin typeface="Calibri" pitchFamily="34" charset="0"/>
                 <a:ea typeface="Calibri" pitchFamily="34" charset="-122"/>
@@ -4627,7 +4671,11 @@
               </a:rPr>
               <a:t>Проверь скобки в указанной строке</a:t>
             </a:r>
-            <a:endParaRPr lang="en-US" sz="1400" dirty="0"/>
+            <a:endParaRPr lang="en-US" sz="2000" dirty="0">
+              <a:solidFill>
+                <a:schemeClr val="bg1"/>
+              </a:solidFill>
+            </a:endParaRPr>
           </a:p>
         </p:txBody>
       </p:sp>
@@ -4683,9 +4731,9 @@
               <a:buNone/>
             </a:pPr>
             <a:r>
-              <a:rPr lang="en-US" sz="1600" b="1" dirty="0">
-                <a:solidFill>
-                  <a:srgbClr val="FFFFFF"/>
+              <a:rPr lang="en-US" sz="2000" b="1" dirty="0">
+                <a:solidFill>
+                  <a:schemeClr val="bg1"/>
                 </a:solidFill>
                 <a:latin typeface="Calibri" pitchFamily="34" charset="0"/>
                 <a:ea typeface="Calibri" pitchFamily="34" charset="-122"/>
@@ -4693,7 +4741,11 @@
               </a:rPr>
               <a:t>Написано Print</a:t>
             </a:r>
-            <a:endParaRPr lang="en-US" sz="1600" dirty="0"/>
+            <a:endParaRPr lang="en-US" sz="2000" dirty="0">
+              <a:solidFill>
+                <a:schemeClr val="bg1"/>
+              </a:solidFill>
+            </a:endParaRPr>
           </a:p>
         </p:txBody>
       </p:sp>
@@ -4722,9 +4774,9 @@
               <a:buNone/>
             </a:pPr>
             <a:r>
-              <a:rPr lang="en-US" sz="1300" dirty="0">
-                <a:solidFill>
-                  <a:srgbClr val="4FD1E0"/>
+              <a:rPr lang="en-US" sz="2000" dirty="0">
+                <a:solidFill>
+                  <a:schemeClr val="bg1"/>
                 </a:solidFill>
                 <a:latin typeface="Consolas" pitchFamily="34" charset="0"/>
                 <a:ea typeface="Consolas" pitchFamily="34" charset="-122"/>
@@ -4732,7 +4784,11 @@
               </a:rPr>
               <a:t>name 'Print' is not defined</a:t>
             </a:r>
-            <a:endParaRPr lang="en-US" sz="1300" dirty="0"/>
+            <a:endParaRPr lang="en-US" sz="2000" dirty="0">
+              <a:solidFill>
+                <a:schemeClr val="bg1"/>
+              </a:solidFill>
+            </a:endParaRPr>
           </a:p>
         </p:txBody>
       </p:sp>
@@ -4761,9 +4817,9 @@
               <a:buNone/>
             </a:pPr>
             <a:r>
-              <a:rPr lang="en-US" sz="1400" dirty="0">
-                <a:solidFill>
-                  <a:srgbClr val="A9A3C4"/>
+              <a:rPr lang="en-US" sz="2000" dirty="0">
+                <a:solidFill>
+                  <a:schemeClr val="bg1"/>
                 </a:solidFill>
                 <a:latin typeface="Calibri" pitchFamily="34" charset="0"/>
                 <a:ea typeface="Calibri" pitchFamily="34" charset="-122"/>
@@ -4771,7 +4827,11 @@
               </a:rPr>
               <a:t>Пиши print маленькими буквами</a:t>
             </a:r>
-            <a:endParaRPr lang="en-US" sz="1400" dirty="0"/>
+            <a:endParaRPr lang="en-US" sz="2000" dirty="0">
+              <a:solidFill>
+                <a:schemeClr val="bg1"/>
+              </a:solidFill>
+            </a:endParaRPr>
           </a:p>
         </p:txBody>
       </p:sp>
@@ -4827,9 +4887,9 @@
               <a:buNone/>
             </a:pPr>
             <a:r>
-              <a:rPr lang="en-US" sz="1600" b="1" dirty="0">
-                <a:solidFill>
-                  <a:srgbClr val="FFFFFF"/>
+              <a:rPr lang="en-US" sz="2000" b="1" dirty="0">
+                <a:solidFill>
+                  <a:schemeClr val="bg1"/>
                 </a:solidFill>
                 <a:latin typeface="Calibri" pitchFamily="34" charset="0"/>
                 <a:ea typeface="Calibri" pitchFamily="34" charset="-122"/>
@@ -4837,7 +4897,11 @@
               </a:rPr>
               <a:t>Лишний пробел в начале</a:t>
             </a:r>
-            <a:endParaRPr lang="en-US" sz="1600" dirty="0"/>
+            <a:endParaRPr lang="en-US" sz="2000" dirty="0">
+              <a:solidFill>
+                <a:schemeClr val="bg1"/>
+              </a:solidFill>
+            </a:endParaRPr>
           </a:p>
         </p:txBody>
       </p:sp>
@@ -4866,9 +4930,9 @@
               <a:buNone/>
             </a:pPr>
             <a:r>
-              <a:rPr lang="en-US" sz="1300" dirty="0">
-                <a:solidFill>
-                  <a:srgbClr val="4FD1E0"/>
+              <a:rPr lang="en-US" sz="2000" dirty="0">
+                <a:solidFill>
+                  <a:schemeClr val="bg1"/>
                 </a:solidFill>
                 <a:latin typeface="Consolas" pitchFamily="34" charset="0"/>
                 <a:ea typeface="Consolas" pitchFamily="34" charset="-122"/>
@@ -4876,7 +4940,11 @@
               </a:rPr>
               <a:t>unexpected indent</a:t>
             </a:r>
-            <a:endParaRPr lang="en-US" sz="1300" dirty="0"/>
+            <a:endParaRPr lang="en-US" sz="2000" dirty="0">
+              <a:solidFill>
+                <a:schemeClr val="bg1"/>
+              </a:solidFill>
+            </a:endParaRPr>
           </a:p>
         </p:txBody>
       </p:sp>
@@ -4905,9 +4973,9 @@
               <a:buNone/>
             </a:pPr>
             <a:r>
-              <a:rPr lang="en-US" sz="1400" dirty="0">
-                <a:solidFill>
-                  <a:srgbClr val="A9A3C4"/>
+              <a:rPr lang="en-US" sz="2000" dirty="0">
+                <a:solidFill>
+                  <a:schemeClr val="bg1"/>
                 </a:solidFill>
                 <a:latin typeface="Calibri" pitchFamily="34" charset="0"/>
                 <a:ea typeface="Calibri" pitchFamily="34" charset="-122"/>
@@ -4915,7 +4983,11 @@
               </a:rPr>
               <a:t>Убери пробелы перед print</a:t>
             </a:r>
-            <a:endParaRPr lang="en-US" sz="1400" dirty="0"/>
+            <a:endParaRPr lang="en-US" sz="2000" dirty="0">
+              <a:solidFill>
+                <a:schemeClr val="bg1"/>
+              </a:solidFill>
+            </a:endParaRPr>
           </a:p>
         </p:txBody>
       </p:sp>
@@ -5212,9 +5284,9 @@
               <a:buNone/>
             </a:pPr>
             <a:r>
-              <a:rPr lang="en-US" sz="1600" dirty="0">
-                <a:solidFill>
-                  <a:srgbClr val="4FD1E0"/>
+              <a:rPr lang="en-US" sz="2000" dirty="0">
+                <a:solidFill>
+                  <a:schemeClr val="bg1"/>
                 </a:solidFill>
                 <a:latin typeface="Consolas" pitchFamily="34" charset="0"/>
                 <a:ea typeface="Consolas" pitchFamily="34" charset="-122"/>
@@ -5222,7 +5294,11 @@
               </a:rPr>
               <a:t>print("Привет</a:t>
             </a:r>
-            <a:endParaRPr lang="en-US" sz="1600" dirty="0"/>
+            <a:endParaRPr lang="en-US" sz="2000" dirty="0">
+              <a:solidFill>
+                <a:schemeClr val="bg1"/>
+              </a:solidFill>
+            </a:endParaRPr>
           </a:p>
           <a:p>
             <a:pPr marL="0" indent="0">
@@ -5232,9 +5308,9 @@
               <a:buNone/>
             </a:pPr>
             <a:r>
-              <a:rPr lang="en-US" sz="1600" dirty="0">
-                <a:solidFill>
-                  <a:srgbClr val="4FD1E0"/>
+              <a:rPr lang="en-US" sz="2000" dirty="0">
+                <a:solidFill>
+                  <a:schemeClr val="bg1"/>
                 </a:solidFill>
                 <a:latin typeface="Consolas" pitchFamily="34" charset="0"/>
                 <a:ea typeface="Consolas" pitchFamily="34" charset="-122"/>
@@ -5242,7 +5318,11 @@
               </a:rPr>
               <a:t>Print("Hello")</a:t>
             </a:r>
-            <a:endParaRPr lang="en-US" sz="1600" dirty="0"/>
+            <a:endParaRPr lang="en-US" sz="2000" dirty="0">
+              <a:solidFill>
+                <a:schemeClr val="bg1"/>
+              </a:solidFill>
+            </a:endParaRPr>
           </a:p>
           <a:p>
             <a:pPr marL="0" indent="0">
@@ -5252,9 +5332,9 @@
               <a:buNone/>
             </a:pPr>
             <a:r>
-              <a:rPr lang="en-US" sz="1600" dirty="0">
-                <a:solidFill>
-                  <a:srgbClr val="4FD1E0"/>
+              <a:rPr lang="en-US" sz="2000" dirty="0">
+                <a:solidFill>
+                  <a:schemeClr val="bg1"/>
                 </a:solidFill>
                 <a:latin typeface="Consolas" pitchFamily="34" charset="0"/>
                 <a:ea typeface="Consolas" pitchFamily="34" charset="-122"/>
@@ -5262,7 +5342,11 @@
               </a:rPr>
               <a:t>  print("bye")</a:t>
             </a:r>
-            <a:endParaRPr lang="en-US" sz="1600" dirty="0"/>
+            <a:endParaRPr lang="en-US" sz="2000" dirty="0">
+              <a:solidFill>
+                <a:schemeClr val="bg1"/>
+              </a:solidFill>
+            </a:endParaRPr>
           </a:p>
         </p:txBody>
       </p:sp>
@@ -5291,9 +5375,9 @@
               <a:buNone/>
             </a:pPr>
             <a:r>
-              <a:rPr lang="en-US" sz="1700" i="1" dirty="0">
-                <a:solidFill>
-                  <a:srgbClr val="F2789F"/>
+              <a:rPr lang="en-US" sz="2000" i="1" dirty="0">
+                <a:solidFill>
+                  <a:schemeClr val="bg1"/>
                 </a:solidFill>
                 <a:latin typeface="Calibri" pitchFamily="34" charset="0"/>
                 <a:ea typeface="Calibri" pitchFamily="34" charset="-122"/>
@@ -5301,7 +5385,11 @@
               </a:rPr>
               <a:t>В третьей строке ошибку видно не сразу — смотрите на начало строки.</a:t>
             </a:r>
-            <a:endParaRPr lang="en-US" sz="1700" dirty="0"/>
+            <a:endParaRPr lang="en-US" sz="2000" dirty="0">
+              <a:solidFill>
+                <a:schemeClr val="bg1"/>
+              </a:solidFill>
+            </a:endParaRPr>
           </a:p>
         </p:txBody>
       </p:sp>
@@ -5537,9 +5625,9 @@
               <a:buNone/>
             </a:pPr>
             <a:r>
-              <a:rPr lang="en-US" sz="1600" dirty="0">
-                <a:solidFill>
-                  <a:srgbClr val="4FD1E0"/>
+              <a:rPr lang="en-US" sz="2000" dirty="0">
+                <a:solidFill>
+                  <a:schemeClr val="bg1"/>
                 </a:solidFill>
                 <a:latin typeface="Consolas" pitchFamily="34" charset="0"/>
                 <a:ea typeface="Consolas" pitchFamily="34" charset="-122"/>
@@ -5547,7 +5635,11 @@
               </a:rPr>
               <a:t>imya = "Фаррух"</a:t>
             </a:r>
-            <a:endParaRPr lang="en-US" sz="1600" dirty="0"/>
+            <a:endParaRPr lang="en-US" sz="2000" dirty="0">
+              <a:solidFill>
+                <a:schemeClr val="bg1"/>
+              </a:solidFill>
+            </a:endParaRPr>
           </a:p>
           <a:p>
             <a:pPr marL="0" indent="0">
@@ -5557,9 +5649,9 @@
               <a:buNone/>
             </a:pPr>
             <a:r>
-              <a:rPr lang="en-US" sz="1600" dirty="0">
-                <a:solidFill>
-                  <a:srgbClr val="4FD1E0"/>
+              <a:rPr lang="en-US" sz="2000" dirty="0">
+                <a:solidFill>
+                  <a:schemeClr val="bg1"/>
                 </a:solidFill>
                 <a:latin typeface="Consolas" pitchFamily="34" charset="0"/>
                 <a:ea typeface="Consolas" pitchFamily="34" charset="-122"/>
@@ -5567,7 +5659,11 @@
               </a:rPr>
               <a:t>klass = 10</a:t>
             </a:r>
-            <a:endParaRPr lang="en-US" sz="1600" dirty="0"/>
+            <a:endParaRPr lang="en-US" sz="2000" dirty="0">
+              <a:solidFill>
+                <a:schemeClr val="bg1"/>
+              </a:solidFill>
+            </a:endParaRPr>
           </a:p>
           <a:p>
             <a:pPr marL="0" indent="0">
@@ -5577,9 +5673,9 @@
               <a:buNone/>
             </a:pPr>
             <a:r>
-              <a:rPr lang="en-US" sz="1600" dirty="0">
-                <a:solidFill>
-                  <a:srgbClr val="4FD1E0"/>
+              <a:rPr lang="en-US" sz="2000" dirty="0">
+                <a:solidFill>
+                  <a:schemeClr val="bg1"/>
                 </a:solidFill>
                 <a:latin typeface="Consolas" pitchFamily="34" charset="0"/>
                 <a:ea typeface="Consolas" pitchFamily="34" charset="-122"/>
@@ -5587,7 +5683,11 @@
               </a:rPr>
               <a:t>ball = 4.5</a:t>
             </a:r>
-            <a:endParaRPr lang="en-US" sz="1600" dirty="0"/>
+            <a:endParaRPr lang="en-US" sz="2000" dirty="0">
+              <a:solidFill>
+                <a:schemeClr val="bg1"/>
+              </a:solidFill>
+            </a:endParaRPr>
           </a:p>
           <a:p>
             <a:pPr marL="0" indent="0">
@@ -5596,7 +5696,11 @@
               </a:lnSpc>
               <a:buNone/>
             </a:pPr>
-            <a:endParaRPr lang="en-US" sz="1600" dirty="0"/>
+            <a:endParaRPr lang="en-US" sz="2000" dirty="0">
+              <a:solidFill>
+                <a:schemeClr val="bg1"/>
+              </a:solidFill>
+            </a:endParaRPr>
           </a:p>
           <a:p>
             <a:pPr marL="0" indent="0">
@@ -5606,9 +5710,9 @@
               <a:buNone/>
             </a:pPr>
             <a:r>
-              <a:rPr lang="en-US" sz="1600" dirty="0">
-                <a:solidFill>
-                  <a:srgbClr val="4FD1E0"/>
+              <a:rPr lang="en-US" sz="2000" dirty="0">
+                <a:solidFill>
+                  <a:schemeClr val="bg1"/>
                 </a:solidFill>
                 <a:latin typeface="Consolas" pitchFamily="34" charset="0"/>
                 <a:ea typeface="Consolas" pitchFamily="34" charset="-122"/>
@@ -5616,7 +5720,11 @@
               </a:rPr>
               <a:t>print("Имя:", imya)</a:t>
             </a:r>
-            <a:endParaRPr lang="en-US" sz="1600" dirty="0"/>
+            <a:endParaRPr lang="en-US" sz="2000" dirty="0">
+              <a:solidFill>
+                <a:schemeClr val="bg1"/>
+              </a:solidFill>
+            </a:endParaRPr>
           </a:p>
           <a:p>
             <a:pPr marL="0" indent="0">
@@ -5626,9 +5734,9 @@
               <a:buNone/>
             </a:pPr>
             <a:r>
-              <a:rPr lang="en-US" sz="1600" dirty="0">
-                <a:solidFill>
-                  <a:srgbClr val="4FD1E0"/>
+              <a:rPr lang="en-US" sz="2000" dirty="0">
+                <a:solidFill>
+                  <a:schemeClr val="bg1"/>
                 </a:solidFill>
                 <a:latin typeface="Consolas" pitchFamily="34" charset="0"/>
                 <a:ea typeface="Consolas" pitchFamily="34" charset="-122"/>
@@ -5636,7 +5744,11 @@
               </a:rPr>
               <a:t>print("Класс:", klass)</a:t>
             </a:r>
-            <a:endParaRPr lang="en-US" sz="1600" dirty="0"/>
+            <a:endParaRPr lang="en-US" sz="2000" dirty="0">
+              <a:solidFill>
+                <a:schemeClr val="bg1"/>
+              </a:solidFill>
+            </a:endParaRPr>
           </a:p>
         </p:txBody>
       </p:sp>
@@ -6023,9 +6135,9 @@
               <a:buNone/>
             </a:pPr>
             <a:r>
-              <a:rPr lang="en-US" sz="1500" dirty="0">
-                <a:solidFill>
-                  <a:srgbClr val="4FD1E0"/>
+              <a:rPr lang="en-US" sz="2000" dirty="0">
+                <a:solidFill>
+                  <a:schemeClr val="bg1"/>
                 </a:solidFill>
                 <a:latin typeface="Consolas" pitchFamily="34" charset="0"/>
                 <a:ea typeface="Consolas" pitchFamily="34" charset="-122"/>
@@ -6033,7 +6145,11 @@
               </a:rPr>
               <a:t>Имя: Фаррух</a:t>
             </a:r>
-            <a:endParaRPr lang="en-US" sz="1500" dirty="0"/>
+            <a:endParaRPr lang="en-US" sz="2000" dirty="0">
+              <a:solidFill>
+                <a:schemeClr val="bg1"/>
+              </a:solidFill>
+            </a:endParaRPr>
           </a:p>
           <a:p>
             <a:pPr marL="0" indent="0">
@@ -6043,9 +6159,9 @@
               <a:buNone/>
             </a:pPr>
             <a:r>
-              <a:rPr lang="en-US" sz="1500" dirty="0">
-                <a:solidFill>
-                  <a:srgbClr val="4FD1E0"/>
+              <a:rPr lang="en-US" sz="2000" dirty="0">
+                <a:solidFill>
+                  <a:schemeClr val="bg1"/>
                 </a:solidFill>
                 <a:latin typeface="Consolas" pitchFamily="34" charset="0"/>
                 <a:ea typeface="Consolas" pitchFamily="34" charset="-122"/>
@@ -6053,7 +6169,11 @@
               </a:rPr>
               <a:t>Класс: 10</a:t>
             </a:r>
-            <a:endParaRPr lang="en-US" sz="1500" dirty="0"/>
+            <a:endParaRPr lang="en-US" sz="2000" dirty="0">
+              <a:solidFill>
+                <a:schemeClr val="bg1"/>
+              </a:solidFill>
+            </a:endParaRPr>
           </a:p>
         </p:txBody>
       </p:sp>
@@ -6387,7 +6507,7 @@
         <p:spPr>
           <a:xfrm>
             <a:off x="640080" y="2788920"/>
-            <a:ext cx="6766560" cy="1847088"/>
+            <a:ext cx="7024744" cy="2075688"/>
           </a:xfrm>
           <a:prstGeom prst="roundRect">
             <a:avLst>
@@ -6433,9 +6553,9 @@
               <a:buNone/>
             </a:pPr>
             <a:r>
-              <a:rPr lang="en-US" sz="1600" dirty="0">
-                <a:solidFill>
-                  <a:srgbClr val="4FD1E0"/>
+              <a:rPr lang="en-US" b="1" dirty="0">
+                <a:solidFill>
+                  <a:schemeClr val="bg1"/>
                 </a:solidFill>
                 <a:latin typeface="Consolas" pitchFamily="34" charset="0"/>
                 <a:ea typeface="Consolas" pitchFamily="34" charset="-122"/>
@@ -6443,7 +6563,11 @@
               </a:rPr>
               <a:t>a = "5"</a:t>
             </a:r>
-            <a:endParaRPr lang="en-US" sz="1600" dirty="0"/>
+            <a:endParaRPr lang="en-US" b="1" dirty="0">
+              <a:solidFill>
+                <a:schemeClr val="bg1"/>
+              </a:solidFill>
+            </a:endParaRPr>
           </a:p>
           <a:p>
             <a:pPr marL="0" indent="0">
@@ -6453,9 +6577,9 @@
               <a:buNone/>
             </a:pPr>
             <a:r>
-              <a:rPr lang="en-US" sz="1600" dirty="0">
-                <a:solidFill>
-                  <a:srgbClr val="4FD1E0"/>
+              <a:rPr lang="en-US" b="1" dirty="0">
+                <a:solidFill>
+                  <a:schemeClr val="bg1"/>
                 </a:solidFill>
                 <a:latin typeface="Consolas" pitchFamily="34" charset="0"/>
                 <a:ea typeface="Consolas" pitchFamily="34" charset="-122"/>
@@ -6463,7 +6587,11 @@
               </a:rPr>
               <a:t>b = 5</a:t>
             </a:r>
-            <a:endParaRPr lang="en-US" sz="1600" dirty="0"/>
+            <a:endParaRPr lang="en-US" b="1" dirty="0">
+              <a:solidFill>
+                <a:schemeClr val="bg1"/>
+              </a:solidFill>
+            </a:endParaRPr>
           </a:p>
           <a:p>
             <a:pPr marL="0" indent="0">
@@ -6472,7 +6600,11 @@
               </a:lnSpc>
               <a:buNone/>
             </a:pPr>
-            <a:endParaRPr lang="en-US" sz="1600" dirty="0"/>
+            <a:endParaRPr lang="en-US" b="1" dirty="0">
+              <a:solidFill>
+                <a:schemeClr val="bg1"/>
+              </a:solidFill>
+            </a:endParaRPr>
           </a:p>
           <a:p>
             <a:pPr marL="0" indent="0">
@@ -6482,9 +6614,9 @@
               <a:buNone/>
             </a:pPr>
             <a:r>
-              <a:rPr lang="en-US" sz="1600" dirty="0">
-                <a:solidFill>
-                  <a:srgbClr val="4FD1E0"/>
+              <a:rPr lang="en-US" b="1" dirty="0">
+                <a:solidFill>
+                  <a:schemeClr val="bg1"/>
                 </a:solidFill>
                 <a:latin typeface="Consolas" pitchFamily="34" charset="0"/>
                 <a:ea typeface="Consolas" pitchFamily="34" charset="-122"/>
@@ -6492,7 +6624,11 @@
               </a:rPr>
               <a:t>print(a)</a:t>
             </a:r>
-            <a:endParaRPr lang="en-US" sz="1600" dirty="0"/>
+            <a:endParaRPr lang="en-US" b="1" dirty="0">
+              <a:solidFill>
+                <a:schemeClr val="bg1"/>
+              </a:solidFill>
+            </a:endParaRPr>
           </a:p>
           <a:p>
             <a:pPr marL="0" indent="0">
@@ -6502,9 +6638,9 @@
               <a:buNone/>
             </a:pPr>
             <a:r>
-              <a:rPr lang="en-US" sz="1600" dirty="0">
-                <a:solidFill>
-                  <a:srgbClr val="4FD1E0"/>
+              <a:rPr lang="en-US" b="1" dirty="0">
+                <a:solidFill>
+                  <a:schemeClr val="bg1"/>
                 </a:solidFill>
                 <a:latin typeface="Consolas" pitchFamily="34" charset="0"/>
                 <a:ea typeface="Consolas" pitchFamily="34" charset="-122"/>
@@ -6512,7 +6648,11 @@
               </a:rPr>
               <a:t>print(b)</a:t>
             </a:r>
-            <a:endParaRPr lang="en-US" sz="1600" dirty="0"/>
+            <a:endParaRPr lang="en-US" b="1" dirty="0">
+              <a:solidFill>
+                <a:schemeClr val="bg1"/>
+              </a:solidFill>
+            </a:endParaRPr>
           </a:p>
           <a:p>
             <a:pPr marL="0" indent="0">
@@ -6522,9 +6662,9 @@
               <a:buNone/>
             </a:pPr>
             <a:r>
-              <a:rPr lang="en-US" sz="1600" dirty="0">
-                <a:solidFill>
-                  <a:srgbClr val="4FD1E0"/>
+              <a:rPr lang="en-US" b="1" dirty="0">
+                <a:solidFill>
+                  <a:schemeClr val="bg1"/>
                 </a:solidFill>
                 <a:latin typeface="Consolas" pitchFamily="34" charset="0"/>
                 <a:ea typeface="Consolas" pitchFamily="34" charset="-122"/>
@@ -6532,7 +6672,11 @@
               </a:rPr>
               <a:t>print("a")</a:t>
             </a:r>
-            <a:endParaRPr lang="en-US" sz="1600" dirty="0"/>
+            <a:endParaRPr lang="en-US" b="1" dirty="0">
+              <a:solidFill>
+                <a:schemeClr val="bg1"/>
+              </a:solidFill>
+            </a:endParaRPr>
           </a:p>
         </p:txBody>
       </p:sp>
@@ -8049,9 +8193,9 @@
               <a:buNone/>
             </a:pPr>
             <a:r>
-              <a:rPr lang="en-US" sz="1600" dirty="0">
-                <a:solidFill>
-                  <a:srgbClr val="4FD1E0"/>
+              <a:rPr lang="en-US" sz="2000" dirty="0">
+                <a:solidFill>
+                  <a:schemeClr val="bg1"/>
                 </a:solidFill>
                 <a:latin typeface="Consolas" pitchFamily="34" charset="0"/>
                 <a:ea typeface="Consolas" pitchFamily="34" charset="-122"/>
@@ -8059,7 +8203,11 @@
               </a:rPr>
               <a:t>17 // 5 = ?</a:t>
             </a:r>
-            <a:endParaRPr lang="en-US" sz="1600" dirty="0"/>
+            <a:endParaRPr lang="en-US" sz="2000" dirty="0">
+              <a:solidFill>
+                <a:schemeClr val="bg1"/>
+              </a:solidFill>
+            </a:endParaRPr>
           </a:p>
           <a:p>
             <a:pPr marL="0" indent="0">
@@ -8069,9 +8217,9 @@
               <a:buNone/>
             </a:pPr>
             <a:r>
-              <a:rPr lang="en-US" sz="1600" dirty="0">
-                <a:solidFill>
-                  <a:srgbClr val="4FD1E0"/>
+              <a:rPr lang="en-US" sz="2000" dirty="0">
+                <a:solidFill>
+                  <a:schemeClr val="bg1"/>
                 </a:solidFill>
                 <a:latin typeface="Consolas" pitchFamily="34" charset="0"/>
                 <a:ea typeface="Consolas" pitchFamily="34" charset="-122"/>
@@ -8079,7 +8227,11 @@
               </a:rPr>
               <a:t>17 % 5 = ?</a:t>
             </a:r>
-            <a:endParaRPr lang="en-US" sz="1600" dirty="0"/>
+            <a:endParaRPr lang="en-US" sz="2000" dirty="0">
+              <a:solidFill>
+                <a:schemeClr val="bg1"/>
+              </a:solidFill>
+            </a:endParaRPr>
           </a:p>
         </p:txBody>
       </p:sp>
@@ -8285,9 +8437,9 @@
               <a:buNone/>
             </a:pPr>
             <a:r>
-              <a:rPr lang="en-US" sz="1600" i="1" dirty="0">
-                <a:solidFill>
-                  <a:srgbClr val="A9A3C4"/>
+              <a:rPr lang="en-US" sz="2000" b="1" i="1" dirty="0">
+                <a:solidFill>
+                  <a:schemeClr val="bg1"/>
                 </a:solidFill>
                 <a:latin typeface="Calibri" pitchFamily="34" charset="0"/>
                 <a:ea typeface="Calibri" pitchFamily="34" charset="-122"/>
@@ -8295,7 +8447,11 @@
               </a:rPr>
               <a:t>Не «пригодится потом» — работает вокруг вас каждый день</a:t>
             </a:r>
-            <a:endParaRPr lang="en-US" sz="1600" dirty="0"/>
+            <a:endParaRPr lang="en-US" sz="2000" b="1" dirty="0">
+              <a:solidFill>
+                <a:schemeClr val="bg1"/>
+              </a:solidFill>
+            </a:endParaRPr>
           </a:p>
         </p:txBody>
       </p:sp>
@@ -8360,7 +8516,7 @@
             <a:r>
               <a:rPr lang="en-US" sz="2000" b="1" dirty="0">
                 <a:solidFill>
-                  <a:srgbClr val="8B7CF6"/>
+                  <a:schemeClr val="bg1"/>
                 </a:solidFill>
                 <a:latin typeface="Calibri" pitchFamily="34" charset="0"/>
                 <a:ea typeface="Calibri" pitchFamily="34" charset="-122"/>
@@ -8368,7 +8524,11 @@
               </a:rPr>
               <a:t>Игры</a:t>
             </a:r>
-            <a:endParaRPr lang="en-US" sz="2000" dirty="0"/>
+            <a:endParaRPr lang="en-US" sz="2000" dirty="0">
+              <a:solidFill>
+                <a:schemeClr val="bg1"/>
+              </a:solidFill>
+            </a:endParaRPr>
           </a:p>
         </p:txBody>
       </p:sp>
@@ -8397,7 +8557,7 @@
               <a:buNone/>
             </a:pPr>
             <a:r>
-              <a:rPr lang="en-US" sz="1400" dirty="0">
+              <a:rPr lang="en-US" dirty="0">
                 <a:solidFill>
                   <a:srgbClr val="FFFFFF"/>
                 </a:solidFill>
@@ -8407,7 +8567,7 @@
               </a:rPr>
               <a:t>Нажал W — идёшь вперёд, нажал пробел — прыгаешь. Каждое действие персонажа записано как алгоритм: если нажато то, делай это</a:t>
             </a:r>
-            <a:endParaRPr lang="en-US" sz="1400" dirty="0"/>
+            <a:endParaRPr lang="en-US" dirty="0"/>
           </a:p>
         </p:txBody>
       </p:sp>
@@ -8472,7 +8632,7 @@
             <a:r>
               <a:rPr lang="en-US" sz="2000" b="1" dirty="0">
                 <a:solidFill>
-                  <a:srgbClr val="3DD6A0"/>
+                  <a:schemeClr val="bg1"/>
                 </a:solidFill>
                 <a:latin typeface="Calibri" pitchFamily="34" charset="0"/>
                 <a:ea typeface="Calibri" pitchFamily="34" charset="-122"/>
@@ -8480,7 +8640,11 @@
               </a:rPr>
               <a:t>Зависший телефон</a:t>
             </a:r>
-            <a:endParaRPr lang="en-US" sz="2000" dirty="0"/>
+            <a:endParaRPr lang="en-US" sz="2000" dirty="0">
+              <a:solidFill>
+                <a:schemeClr val="bg1"/>
+              </a:solidFill>
+            </a:endParaRPr>
           </a:p>
         </p:txBody>
       </p:sp>
@@ -8509,7 +8673,7 @@
               <a:buNone/>
             </a:pPr>
             <a:r>
-              <a:rPr lang="en-US" sz="1400" dirty="0">
+              <a:rPr lang="en-US" dirty="0">
                 <a:solidFill>
                   <a:srgbClr val="FFFFFF"/>
                 </a:solidFill>
@@ -8519,7 +8683,7 @@
               </a:rPr>
               <a:t>Программа попала в шаг, из которого нет выхода. Батарейка садится за час. Нарушено свойство конечности</a:t>
             </a:r>
-            <a:endParaRPr lang="en-US" sz="1400" dirty="0"/>
+            <a:endParaRPr lang="en-US" dirty="0"/>
           </a:p>
         </p:txBody>
       </p:sp>
@@ -8584,7 +8748,7 @@
             <a:r>
               <a:rPr lang="en-US" sz="2000" b="1" dirty="0">
                 <a:solidFill>
-                  <a:srgbClr val="4FD1E0"/>
+                  <a:schemeClr val="bg1"/>
                 </a:solidFill>
                 <a:latin typeface="Calibri" pitchFamily="34" charset="0"/>
                 <a:ea typeface="Calibri" pitchFamily="34" charset="-122"/>
@@ -8592,7 +8756,11 @@
               </a:rPr>
               <a:t>Голосовой помощник</a:t>
             </a:r>
-            <a:endParaRPr lang="en-US" sz="2000" dirty="0"/>
+            <a:endParaRPr lang="en-US" sz="2000" dirty="0">
+              <a:solidFill>
+                <a:schemeClr val="bg1"/>
+              </a:solidFill>
+            </a:endParaRPr>
           </a:p>
         </p:txBody>
       </p:sp>
@@ -8621,7 +8789,7 @@
               <a:buNone/>
             </a:pPr>
             <a:r>
-              <a:rPr lang="en-US" sz="1400" dirty="0">
+              <a:rPr lang="en-US" dirty="0">
                 <a:solidFill>
                   <a:srgbClr val="FFFFFF"/>
                 </a:solidFill>
@@ -8631,7 +8799,7 @@
               </a:rPr>
               <a:t>Понимает «включи свет на кухне» и не понимает «включи что-нибудь». Разница — в точности указания</a:t>
             </a:r>
-            <a:endParaRPr lang="en-US" sz="1400" dirty="0"/>
+            <a:endParaRPr lang="en-US" dirty="0"/>
           </a:p>
         </p:txBody>
       </p:sp>
@@ -8696,7 +8864,7 @@
             <a:r>
               <a:rPr lang="en-US" sz="2000" b="1" dirty="0">
                 <a:solidFill>
-                  <a:srgbClr val="F2789F"/>
+                  <a:schemeClr val="bg1"/>
                 </a:solidFill>
                 <a:latin typeface="Calibri" pitchFamily="34" charset="0"/>
                 <a:ea typeface="Calibri" pitchFamily="34" charset="-122"/>
@@ -8704,7 +8872,11 @@
               </a:rPr>
               <a:t>Автопилот в машине</a:t>
             </a:r>
-            <a:endParaRPr lang="en-US" sz="2000" dirty="0"/>
+            <a:endParaRPr lang="en-US" sz="2000" dirty="0">
+              <a:solidFill>
+                <a:schemeClr val="bg1"/>
+              </a:solidFill>
+            </a:endParaRPr>
           </a:p>
         </p:txBody>
       </p:sp>
@@ -8733,7 +8905,7 @@
               <a:buNone/>
             </a:pPr>
             <a:r>
-              <a:rPr lang="en-US" sz="1400" dirty="0">
+              <a:rPr lang="en-US" dirty="0">
                 <a:solidFill>
                   <a:srgbClr val="FFFFFF"/>
                 </a:solidFill>
@@ -8743,7 +8915,7 @@
               </a:rPr>
               <a:t>Решает: тормозить или объезжать. Если указание допускает два толкования — авария</a:t>
             </a:r>
-            <a:endParaRPr lang="en-US" sz="1400" dirty="0"/>
+            <a:endParaRPr lang="en-US" dirty="0"/>
           </a:p>
         </p:txBody>
       </p:sp>
@@ -8772,9 +8944,9 @@
               <a:buNone/>
             </a:pPr>
             <a:r>
-              <a:rPr lang="en-US" sz="1700" i="1" dirty="0">
-                <a:solidFill>
-                  <a:srgbClr val="4FD1E0"/>
+              <a:rPr lang="en-US" sz="2000" b="1" i="1" dirty="0">
+                <a:solidFill>
+                  <a:schemeClr val="bg1"/>
                 </a:solidFill>
                 <a:latin typeface="Calibri" pitchFamily="34" charset="0"/>
                 <a:ea typeface="Calibri" pitchFamily="34" charset="-122"/>
@@ -8782,7 +8954,11 @@
               </a:rPr>
               <a:t>Во всех четырёх случаях работает или ломается одно и то же — алгоритм.</a:t>
             </a:r>
-            <a:endParaRPr lang="en-US" sz="1700" dirty="0"/>
+            <a:endParaRPr lang="en-US" sz="2000" b="1" dirty="0">
+              <a:solidFill>
+                <a:schemeClr val="bg1"/>
+              </a:solidFill>
+            </a:endParaRPr>
           </a:p>
         </p:txBody>
       </p:sp>
@@ -8952,9 +9128,9 @@
               <a:buNone/>
             </a:pPr>
             <a:r>
-              <a:rPr lang="en-US" sz="1600" dirty="0">
-                <a:solidFill>
-                  <a:srgbClr val="4FD1E0"/>
+              <a:rPr lang="en-US" sz="1600" b="1" dirty="0">
+                <a:solidFill>
+                  <a:schemeClr val="bg1"/>
                 </a:solidFill>
                 <a:latin typeface="Consolas" pitchFamily="34" charset="0"/>
                 <a:ea typeface="Consolas" pitchFamily="34" charset="-122"/>
@@ -8962,7 +9138,11 @@
               </a:rPr>
               <a:t>dlina = 6</a:t>
             </a:r>
-            <a:endParaRPr lang="en-US" sz="1600" dirty="0"/>
+            <a:endParaRPr lang="en-US" sz="1600" b="1" dirty="0">
+              <a:solidFill>
+                <a:schemeClr val="bg1"/>
+              </a:solidFill>
+            </a:endParaRPr>
           </a:p>
           <a:p>
             <a:pPr marL="0" indent="0">
@@ -8972,9 +9152,9 @@
               <a:buNone/>
             </a:pPr>
             <a:r>
-              <a:rPr lang="en-US" sz="1600" dirty="0">
-                <a:solidFill>
-                  <a:srgbClr val="4FD1E0"/>
+              <a:rPr lang="en-US" sz="1600" b="1" dirty="0">
+                <a:solidFill>
+                  <a:schemeClr val="bg1"/>
                 </a:solidFill>
                 <a:latin typeface="Consolas" pitchFamily="34" charset="0"/>
                 <a:ea typeface="Consolas" pitchFamily="34" charset="-122"/>
@@ -8982,7 +9162,11 @@
               </a:rPr>
               <a:t>shirina = 4</a:t>
             </a:r>
-            <a:endParaRPr lang="en-US" sz="1600" dirty="0"/>
+            <a:endParaRPr lang="en-US" sz="1600" b="1" dirty="0">
+              <a:solidFill>
+                <a:schemeClr val="bg1"/>
+              </a:solidFill>
+            </a:endParaRPr>
           </a:p>
           <a:p>
             <a:pPr marL="0" indent="0">
@@ -8991,7 +9175,11 @@
               </a:lnSpc>
               <a:buNone/>
             </a:pPr>
-            <a:endParaRPr lang="en-US" sz="1600" dirty="0"/>
+            <a:endParaRPr lang="en-US" sz="1600" b="1" dirty="0">
+              <a:solidFill>
+                <a:schemeClr val="bg1"/>
+              </a:solidFill>
+            </a:endParaRPr>
           </a:p>
           <a:p>
             <a:pPr marL="0" indent="0">
@@ -9001,9 +9189,9 @@
               <a:buNone/>
             </a:pPr>
             <a:r>
-              <a:rPr lang="en-US" sz="1600" dirty="0">
-                <a:solidFill>
-                  <a:srgbClr val="4FD1E0"/>
+              <a:rPr lang="en-US" sz="1600" b="1" dirty="0">
+                <a:solidFill>
+                  <a:schemeClr val="bg1"/>
                 </a:solidFill>
                 <a:latin typeface="Consolas" pitchFamily="34" charset="0"/>
                 <a:ea typeface="Consolas" pitchFamily="34" charset="-122"/>
@@ -9011,7 +9199,11 @@
               </a:rPr>
               <a:t>perimetr = 2 * (dlina + shirina)</a:t>
             </a:r>
-            <a:endParaRPr lang="en-US" sz="1600" dirty="0"/>
+            <a:endParaRPr lang="en-US" sz="1600" b="1" dirty="0">
+              <a:solidFill>
+                <a:schemeClr val="bg1"/>
+              </a:solidFill>
+            </a:endParaRPr>
           </a:p>
           <a:p>
             <a:pPr marL="0" indent="0">
@@ -9021,9 +9213,9 @@
               <a:buNone/>
             </a:pPr>
             <a:r>
-              <a:rPr lang="en-US" sz="1600" dirty="0">
-                <a:solidFill>
-                  <a:srgbClr val="4FD1E0"/>
+              <a:rPr lang="en-US" sz="1600" b="1" dirty="0">
+                <a:solidFill>
+                  <a:schemeClr val="bg1"/>
                 </a:solidFill>
                 <a:latin typeface="Consolas" pitchFamily="34" charset="0"/>
                 <a:ea typeface="Consolas" pitchFamily="34" charset="-122"/>
@@ -9031,7 +9223,11 @@
               </a:rPr>
               <a:t>ploshad = dlina * shirina</a:t>
             </a:r>
-            <a:endParaRPr lang="en-US" sz="1600" dirty="0"/>
+            <a:endParaRPr lang="en-US" sz="1600" b="1" dirty="0">
+              <a:solidFill>
+                <a:schemeClr val="bg1"/>
+              </a:solidFill>
+            </a:endParaRPr>
           </a:p>
           <a:p>
             <a:pPr marL="0" indent="0">
@@ -9040,7 +9236,11 @@
               </a:lnSpc>
               <a:buNone/>
             </a:pPr>
-            <a:endParaRPr lang="en-US" sz="1600" dirty="0"/>
+            <a:endParaRPr lang="en-US" sz="1600" b="1" dirty="0">
+              <a:solidFill>
+                <a:schemeClr val="bg1"/>
+              </a:solidFill>
+            </a:endParaRPr>
           </a:p>
           <a:p>
             <a:pPr marL="0" indent="0">
@@ -9050,9 +9250,9 @@
               <a:buNone/>
             </a:pPr>
             <a:r>
-              <a:rPr lang="en-US" sz="1600" dirty="0">
-                <a:solidFill>
-                  <a:srgbClr val="4FD1E0"/>
+              <a:rPr lang="en-US" sz="1600" b="1" dirty="0">
+                <a:solidFill>
+                  <a:schemeClr val="bg1"/>
                 </a:solidFill>
                 <a:latin typeface="Consolas" pitchFamily="34" charset="0"/>
                 <a:ea typeface="Consolas" pitchFamily="34" charset="-122"/>
@@ -9060,7 +9260,11 @@
               </a:rPr>
               <a:t>print("Периметр:", perimetr)</a:t>
             </a:r>
-            <a:endParaRPr lang="en-US" sz="1600" dirty="0"/>
+            <a:endParaRPr lang="en-US" sz="1600" b="1" dirty="0">
+              <a:solidFill>
+                <a:schemeClr val="bg1"/>
+              </a:solidFill>
+            </a:endParaRPr>
           </a:p>
           <a:p>
             <a:pPr marL="0" indent="0">
@@ -9070,9 +9274,9 @@
               <a:buNone/>
             </a:pPr>
             <a:r>
-              <a:rPr lang="en-US" sz="1600" dirty="0">
-                <a:solidFill>
-                  <a:srgbClr val="4FD1E0"/>
+              <a:rPr lang="en-US" sz="1600" b="1" dirty="0">
+                <a:solidFill>
+                  <a:schemeClr val="bg1"/>
                 </a:solidFill>
                 <a:latin typeface="Consolas" pitchFamily="34" charset="0"/>
                 <a:ea typeface="Consolas" pitchFamily="34" charset="-122"/>
@@ -9080,7 +9284,11 @@
               </a:rPr>
               <a:t>print("Площадь:", ploshad)</a:t>
             </a:r>
-            <a:endParaRPr lang="en-US" sz="1600" dirty="0"/>
+            <a:endParaRPr lang="en-US" sz="1600" b="1" dirty="0">
+              <a:solidFill>
+                <a:schemeClr val="bg1"/>
+              </a:solidFill>
+            </a:endParaRPr>
           </a:p>
         </p:txBody>
       </p:sp>
@@ -10917,9 +11125,9 @@
               <a:buNone/>
             </a:pPr>
             <a:r>
-              <a:rPr lang="en-US" sz="1500" dirty="0">
-                <a:solidFill>
-                  <a:srgbClr val="FFFFFF"/>
+              <a:rPr lang="en-US" sz="2000" b="1" dirty="0">
+                <a:solidFill>
+                  <a:schemeClr val="bg1"/>
                 </a:solidFill>
                 <a:latin typeface="Calibri" pitchFamily="34" charset="0"/>
                 <a:ea typeface="Calibri" pitchFamily="34" charset="-122"/>
@@ -10927,7 +11135,11 @@
               </a:rPr>
               <a:t>Блок-схема алгоритма «перейти улицу по светофору». Оба выхода из ромба подписать словами «да» и «нет»</a:t>
             </a:r>
-            <a:endParaRPr lang="en-US" sz="1500" dirty="0"/>
+            <a:endParaRPr lang="en-US" sz="2000" b="1" dirty="0">
+              <a:solidFill>
+                <a:schemeClr val="bg1"/>
+              </a:solidFill>
+            </a:endParaRPr>
           </a:p>
         </p:txBody>
       </p:sp>
@@ -11022,7 +11234,7 @@
               <a:buNone/>
             </a:pPr>
             <a:r>
-              <a:rPr lang="en-US" sz="1500" dirty="0">
+              <a:rPr lang="en-US" sz="2000" b="1" dirty="0">
                 <a:solidFill>
                   <a:srgbClr val="FFFFFF"/>
                 </a:solidFill>
@@ -11032,7 +11244,7 @@
               </a:rPr>
               <a:t>Записать в тетради программу расчёта периметра и указать, что она выведет при длине 10 и ширине 3</a:t>
             </a:r>
-            <a:endParaRPr lang="en-US" sz="1500" dirty="0"/>
+            <a:endParaRPr lang="en-US" sz="2000" b="1" dirty="0"/>
           </a:p>
         </p:txBody>
       </p:sp>
@@ -11127,7 +11339,7 @@
               <a:buNone/>
             </a:pPr>
             <a:r>
-              <a:rPr lang="en-US" sz="1500" dirty="0">
+              <a:rPr lang="en-US" sz="2000" b="1" dirty="0">
                 <a:solidFill>
                   <a:srgbClr val="FFFFFF"/>
                 </a:solidFill>
@@ -11137,7 +11349,7 @@
               </a:rPr>
               <a:t>Программа выводит сведения о себе четырьмя строками с использованием переменных</a:t>
             </a:r>
-            <a:endParaRPr lang="en-US" sz="1500" dirty="0"/>
+            <a:endParaRPr lang="en-US" sz="2000" b="1" dirty="0"/>
           </a:p>
         </p:txBody>
       </p:sp>
@@ -11842,8 +12054,8 @@
         </p:nvSpPr>
         <p:spPr>
           <a:xfrm>
-            <a:off x="640080" y="1600200"/>
-            <a:ext cx="6766560" cy="1828800"/>
+            <a:off x="640080" y="1417320"/>
+            <a:ext cx="6766560" cy="2331720"/>
           </a:xfrm>
           <a:prstGeom prst="roundRect">
             <a:avLst>
@@ -11892,7 +12104,7 @@
               <a:buNone/>
             </a:pPr>
             <a:r>
-              <a:rPr lang="en-US" sz="1900" dirty="0">
+              <a:rPr lang="en-US" sz="2800" dirty="0">
                 <a:solidFill>
                   <a:srgbClr val="FFFFFF"/>
                 </a:solidFill>
@@ -11902,7 +12114,7 @@
               </a:rPr>
               <a:t>Алгоритм — точное и понятное предписание исполнителю выполнить конечную последовательность действий, приводящую к решению задачи.</a:t>
             </a:r>
-            <a:endParaRPr lang="en-US" sz="1900" dirty="0"/>
+            <a:endParaRPr lang="en-US" sz="2800" dirty="0"/>
           </a:p>
         </p:txBody>
       </p:sp>
@@ -11920,7 +12132,7 @@
         </p:nvSpPr>
         <p:spPr>
           <a:xfrm>
-            <a:off x="7772400" y="1645920"/>
+            <a:off x="7690104" y="1371600"/>
             <a:ext cx="3749040" cy="365760"/>
           </a:xfrm>
           <a:prstGeom prst="rect">
@@ -11937,7 +12149,7 @@
               <a:buNone/>
             </a:pPr>
             <a:r>
-              <a:rPr lang="en-US" sz="2000" b="1" dirty="0">
+              <a:rPr lang="en-US" sz="2800" b="1" dirty="0">
                 <a:solidFill>
                   <a:srgbClr val="4FD1E0"/>
                 </a:solidFill>
@@ -11947,7 +12159,7 @@
               </a:rPr>
               <a:t>Исполнитель</a:t>
             </a:r>
-            <a:endParaRPr lang="en-US" sz="2000" dirty="0"/>
+            <a:endParaRPr lang="en-US" sz="2800" dirty="0"/>
           </a:p>
         </p:txBody>
       </p:sp>
@@ -11986,9 +12198,9 @@
               <a:buChar char="•"/>
             </a:pPr>
             <a:r>
-              <a:rPr lang="en-US" sz="1600" dirty="0">
-                <a:solidFill>
-                  <a:srgbClr val="A9A3C4"/>
+              <a:rPr lang="en-US" sz="2800" b="1" dirty="0">
+                <a:solidFill>
+                  <a:schemeClr val="bg1"/>
                 </a:solidFill>
                 <a:latin typeface="Calibri" pitchFamily="34" charset="0"/>
                 <a:ea typeface="Calibri" pitchFamily="34" charset="-122"/>
@@ -11996,7 +12208,11 @@
               </a:rPr>
               <a:t>человек</a:t>
             </a:r>
-            <a:endParaRPr lang="en-US" sz="1600" dirty="0"/>
+            <a:endParaRPr lang="en-US" sz="2800" b="1" dirty="0">
+              <a:solidFill>
+                <a:schemeClr val="bg1"/>
+              </a:solidFill>
+            </a:endParaRPr>
           </a:p>
           <a:p>
             <a:pPr marL="342900" indent="-342900">
@@ -12007,9 +12223,9 @@
               <a:buChar char="•"/>
             </a:pPr>
             <a:r>
-              <a:rPr lang="en-US" sz="1600" dirty="0">
-                <a:solidFill>
-                  <a:srgbClr val="A9A3C4"/>
+              <a:rPr lang="en-US" sz="2800" b="1" dirty="0">
+                <a:solidFill>
+                  <a:schemeClr val="bg1"/>
                 </a:solidFill>
                 <a:latin typeface="Calibri" pitchFamily="34" charset="0"/>
                 <a:ea typeface="Calibri" pitchFamily="34" charset="-122"/>
@@ -12017,7 +12233,11 @@
               </a:rPr>
               <a:t>устройство</a:t>
             </a:r>
-            <a:endParaRPr lang="en-US" sz="1600" dirty="0"/>
+            <a:endParaRPr lang="en-US" sz="2800" b="1" dirty="0">
+              <a:solidFill>
+                <a:schemeClr val="bg1"/>
+              </a:solidFill>
+            </a:endParaRPr>
           </a:p>
           <a:p>
             <a:pPr marL="342900" indent="-342900">
@@ -12028,9 +12248,9 @@
               <a:buChar char="•"/>
             </a:pPr>
             <a:r>
-              <a:rPr lang="en-US" sz="1600" dirty="0">
-                <a:solidFill>
-                  <a:srgbClr val="A9A3C4"/>
+              <a:rPr lang="en-US" sz="2800" b="1" dirty="0">
+                <a:solidFill>
+                  <a:schemeClr val="bg1"/>
                 </a:solidFill>
                 <a:latin typeface="Calibri" pitchFamily="34" charset="0"/>
                 <a:ea typeface="Calibri" pitchFamily="34" charset="-122"/>
@@ -12038,7 +12258,11 @@
               </a:rPr>
               <a:t>компьютер</a:t>
             </a:r>
-            <a:endParaRPr lang="en-US" sz="1600" dirty="0"/>
+            <a:endParaRPr lang="en-US" sz="2800" b="1" dirty="0">
+              <a:solidFill>
+                <a:schemeClr val="bg1"/>
+              </a:solidFill>
+            </a:endParaRPr>
           </a:p>
         </p:txBody>
       </p:sp>
@@ -12056,7 +12280,7 @@
         </p:nvSpPr>
         <p:spPr>
           <a:xfrm>
-            <a:off x="640080" y="3749040"/>
+            <a:off x="640080" y="3946622"/>
             <a:ext cx="10881360" cy="457200"/>
           </a:xfrm>
           <a:prstGeom prst="rect">
@@ -12073,9 +12297,9 @@
               <a:buNone/>
             </a:pPr>
             <a:r>
-              <a:rPr lang="en-US" sz="1600" i="1" dirty="0">
-                <a:solidFill>
-                  <a:srgbClr val="A9A3C4"/>
+              <a:rPr lang="en-US" sz="2400" b="1" i="1" dirty="0">
+                <a:solidFill>
+                  <a:schemeClr val="bg1"/>
                 </a:solidFill>
                 <a:latin typeface="Calibri" pitchFamily="34" charset="0"/>
                 <a:ea typeface="Calibri" pitchFamily="34" charset="-122"/>
@@ -12083,7 +12307,11 @@
               </a:rPr>
               <a:t>Одно и то же указание может быть алгоритмом для одного исполнителя и не быть им для другого.</a:t>
             </a:r>
-            <a:endParaRPr lang="en-US" sz="1600" dirty="0"/>
+            <a:endParaRPr lang="en-US" sz="2400" b="1" dirty="0">
+              <a:solidFill>
+                <a:schemeClr val="bg1"/>
+              </a:solidFill>
+            </a:endParaRPr>
           </a:p>
         </p:txBody>
       </p:sp>
@@ -12101,7 +12329,7 @@
         </p:nvSpPr>
         <p:spPr>
           <a:xfrm>
-            <a:off x="640080" y="4434840"/>
+            <a:off x="640080" y="4678142"/>
             <a:ext cx="2514600" cy="841248"/>
           </a:xfrm>
           <a:prstGeom prst="roundRect">
@@ -12134,7 +12362,7 @@
         </p:nvSpPr>
         <p:spPr>
           <a:xfrm>
-            <a:off x="777240" y="4434840"/>
+            <a:off x="752856" y="4709160"/>
             <a:ext cx="2240280" cy="841248"/>
           </a:xfrm>
           <a:prstGeom prst="rect">
@@ -12179,7 +12407,7 @@
         </p:nvSpPr>
         <p:spPr>
           <a:xfrm>
-            <a:off x="3401568" y="4434840"/>
+            <a:off x="3411340" y="4678142"/>
             <a:ext cx="2514600" cy="841248"/>
           </a:xfrm>
           <a:prstGeom prst="roundRect">
@@ -12212,7 +12440,7 @@
         </p:nvSpPr>
         <p:spPr>
           <a:xfrm>
-            <a:off x="3538728" y="4434840"/>
+            <a:off x="3607308" y="4759004"/>
             <a:ext cx="2240280" cy="841248"/>
           </a:xfrm>
           <a:prstGeom prst="rect">
@@ -12257,7 +12485,7 @@
         </p:nvSpPr>
         <p:spPr>
           <a:xfrm>
-            <a:off x="6163056" y="4434840"/>
+            <a:off x="6210660" y="4678142"/>
             <a:ext cx="2514600" cy="841248"/>
           </a:xfrm>
           <a:prstGeom prst="roundRect">
@@ -12290,7 +12518,7 @@
         </p:nvSpPr>
         <p:spPr>
           <a:xfrm>
-            <a:off x="6300216" y="4434840"/>
+            <a:off x="6300216" y="4694816"/>
             <a:ext cx="2240280" cy="841248"/>
           </a:xfrm>
           <a:prstGeom prst="rect">
@@ -12335,7 +12563,7 @@
         </p:nvSpPr>
         <p:spPr>
           <a:xfrm>
-            <a:off x="8924544" y="4434840"/>
+            <a:off x="8914772" y="4694278"/>
             <a:ext cx="2514600" cy="841248"/>
           </a:xfrm>
           <a:prstGeom prst="roundRect">
@@ -12353,6 +12581,13 @@
             <a:prstDash val="solid"/>
           </a:ln>
         </p:spPr>
+        <p:txBody>
+          <a:bodyPr/>
+          <a:lstStyle/>
+          <a:p>
+            <a:endParaRPr lang="ru-RU" dirty="0"/>
+          </a:p>
+        </p:txBody>
       </p:sp>
       <p:sp>
         <p:nvSpPr>
@@ -12368,7 +12603,7 @@
         </p:nvSpPr>
         <p:spPr>
           <a:xfrm>
-            <a:off x="9061704" y="4434840"/>
+            <a:off x="9061704" y="4730138"/>
             <a:ext cx="2240280" cy="841248"/>
           </a:xfrm>
           <a:prstGeom prst="rect">
@@ -12525,7 +12760,7 @@
           <a:lstStyle/>
           <a:p>
             <a:r>
-              <a:rPr lang="ru-RU" b="1" dirty="0">
+              <a:rPr lang="ru-RU" sz="2000" b="1" dirty="0">
                 <a:solidFill>
                   <a:srgbClr val="FFFFFF"/>
                 </a:solidFill>
@@ -12537,7 +12772,7 @@
             </a:r>
           </a:p>
           <a:p>
-            <a:endParaRPr lang="ru-RU" b="1" dirty="0">
+            <a:endParaRPr lang="ru-RU" sz="2000" b="1" dirty="0">
               <a:solidFill>
                 <a:srgbClr val="FFFFFF"/>
               </a:solidFill>
@@ -12548,7 +12783,7 @@
           </a:p>
           <a:p>
             <a:r>
-              <a:rPr lang="ru-RU" b="1" dirty="0">
+              <a:rPr lang="ru-RU" sz="2000" b="1" dirty="0">
                 <a:solidFill>
                   <a:srgbClr val="FFFFFF"/>
                 </a:solidFill>
@@ -12560,7 +12795,7 @@
             </a:r>
           </a:p>
           <a:p>
-            <a:endParaRPr lang="ru-RU" b="1" dirty="0">
+            <a:endParaRPr lang="ru-RU" sz="2000" b="1" dirty="0">
               <a:solidFill>
                 <a:srgbClr val="FFFFFF"/>
               </a:solidFill>
@@ -12571,7 +12806,7 @@
           </a:p>
           <a:p>
             <a:r>
-              <a:rPr lang="ru-RU" b="1" dirty="0">
+              <a:rPr lang="ru-RU" sz="2000" b="1" dirty="0">
                 <a:solidFill>
                   <a:srgbClr val="FFFFFF"/>
                 </a:solidFill>
@@ -12582,7 +12817,7 @@
               <a:t>Написал книгу «Об индийском счёте» — </a:t>
             </a:r>
             <a:r>
-              <a:rPr lang="en-US" b="1" dirty="0">
+              <a:rPr lang="en-US" sz="2000" b="1" dirty="0">
                 <a:solidFill>
                   <a:srgbClr val="FFFFFF"/>
                 </a:solidFill>
@@ -12593,7 +12828,7 @@
               <a:t> </a:t>
             </a:r>
             <a:r>
-              <a:rPr lang="ru-RU" b="1" dirty="0">
+              <a:rPr lang="ru-RU" sz="2000" b="1" dirty="0">
                 <a:solidFill>
                   <a:srgbClr val="FFFFFF"/>
                 </a:solidFill>
@@ -12605,7 +12840,7 @@
             </a:r>
           </a:p>
           <a:p>
-            <a:endParaRPr lang="ru-RU" b="1" dirty="0">
+            <a:endParaRPr lang="ru-RU" sz="2000" b="1" dirty="0">
               <a:solidFill>
                 <a:srgbClr val="FFFFFF"/>
               </a:solidFill>
@@ -12616,7 +12851,7 @@
           </a:p>
           <a:p>
             <a:r>
-              <a:rPr lang="ru-RU" b="1" dirty="0">
+              <a:rPr lang="ru-RU" sz="2000" b="1" dirty="0">
                 <a:solidFill>
                   <a:srgbClr val="FFFFFF"/>
                 </a:solidFill>
@@ -12627,7 +12862,7 @@
               <a:t>В книге были чёткие пошаговые правила:</a:t>
             </a:r>
             <a:r>
-              <a:rPr lang="en-US" b="1" dirty="0">
+              <a:rPr lang="en-US" sz="2000" b="1" dirty="0">
                 <a:solidFill>
                   <a:srgbClr val="FFFFFF"/>
                 </a:solidFill>
@@ -12638,7 +12873,7 @@
               <a:t> </a:t>
             </a:r>
             <a:r>
-              <a:rPr lang="ru-RU" b="1" dirty="0">
+              <a:rPr lang="ru-RU" sz="2000" b="1" dirty="0">
                 <a:solidFill>
                   <a:srgbClr val="FFFFFF"/>
                 </a:solidFill>
@@ -12650,7 +12885,7 @@
             </a:r>
           </a:p>
           <a:p>
-            <a:endParaRPr lang="ru-RU" b="1" dirty="0">
+            <a:endParaRPr lang="ru-RU" sz="2000" b="1" dirty="0">
               <a:solidFill>
                 <a:srgbClr val="FFFFFF"/>
               </a:solidFill>
@@ -12661,7 +12896,7 @@
           </a:p>
           <a:p>
             <a:r>
-              <a:rPr lang="ru-RU" b="1" dirty="0">
+              <a:rPr lang="ru-RU" sz="2000" b="1" dirty="0">
                 <a:solidFill>
                   <a:srgbClr val="FFFFFF"/>
                 </a:solidFill>
@@ -12672,7 +12907,7 @@
               <a:t>Латинский перевод его имени → </a:t>
             </a:r>
             <a:r>
-              <a:rPr lang="ru-RU" b="1" dirty="0" err="1">
+              <a:rPr lang="ru-RU" sz="2000" b="1" dirty="0" err="1">
                 <a:solidFill>
                   <a:srgbClr val="FFFFFF"/>
                 </a:solidFill>
@@ -12682,7 +12917,7 @@
               </a:rPr>
               <a:t>Algoritmi</a:t>
             </a:r>
-            <a:endParaRPr lang="ru-RU" b="1" dirty="0">
+            <a:endParaRPr lang="ru-RU" sz="2000" b="1" dirty="0">
               <a:solidFill>
                 <a:srgbClr val="FFFFFF"/>
               </a:solidFill>
@@ -12693,7 +12928,7 @@
           </a:p>
           <a:p>
             <a:r>
-              <a:rPr lang="ru-RU" b="1" dirty="0">
+              <a:rPr lang="ru-RU" sz="2000" b="1" dirty="0">
                 <a:solidFill>
                   <a:srgbClr val="FFFFFF"/>
                 </a:solidFill>
@@ -12703,7 +12938,7 @@
               </a:rPr>
               <a:t>Отсюда → АЛГОРИТМ</a:t>
             </a:r>
-            <a:endParaRPr lang="en-US" b="1" dirty="0">
+            <a:endParaRPr lang="en-US" sz="2000" b="1" dirty="0">
               <a:latin typeface="Cambria" panose="02040503050406030204" pitchFamily="18" charset="0"/>
               <a:ea typeface="Cambria" panose="02040503050406030204" pitchFamily="18" charset="0"/>
             </a:endParaRPr>
@@ -12837,9 +13072,9 @@
               <a:buNone/>
             </a:pPr>
             <a:r>
-              <a:rPr lang="en-US" sz="1600" i="1" dirty="0">
-                <a:solidFill>
-                  <a:srgbClr val="A9A3C4"/>
+              <a:rPr lang="en-US" sz="2000" b="1" i="1" dirty="0">
+                <a:solidFill>
+                  <a:schemeClr val="bg1"/>
                 </a:solidFill>
                 <a:latin typeface="Calibri" pitchFamily="34" charset="0"/>
                 <a:ea typeface="Calibri" pitchFamily="34" charset="-122"/>
@@ -12847,7 +13082,11 @@
               </a:rPr>
               <a:t>Проверьте каждую инструкцию — можно ли её выполнить однозначно</a:t>
             </a:r>
-            <a:endParaRPr lang="en-US" sz="1600" dirty="0"/>
+            <a:endParaRPr lang="en-US" sz="2000" b="1" dirty="0">
+              <a:solidFill>
+                <a:schemeClr val="bg1"/>
+              </a:solidFill>
+            </a:endParaRPr>
           </a:p>
         </p:txBody>
       </p:sp>
@@ -12942,9 +13181,9 @@
               <a:buNone/>
             </a:pPr>
             <a:r>
-              <a:rPr lang="en-US" sz="1500" dirty="0">
-                <a:solidFill>
-                  <a:srgbClr val="A9A3C4"/>
+              <a:rPr lang="en-US" sz="2000" b="1" dirty="0">
+                <a:solidFill>
+                  <a:schemeClr val="bg1"/>
                 </a:solidFill>
                 <a:latin typeface="Calibri" pitchFamily="34" charset="0"/>
                 <a:ea typeface="Calibri" pitchFamily="34" charset="-122"/>
@@ -12952,7 +13191,11 @@
               </a:rPr>
               <a:t>Сколько — «немного»?</a:t>
             </a:r>
-            <a:endParaRPr lang="en-US" sz="1500" dirty="0"/>
+            <a:endParaRPr lang="en-US" sz="2000" b="1" dirty="0">
+              <a:solidFill>
+                <a:schemeClr val="bg1"/>
+              </a:solidFill>
+            </a:endParaRPr>
           </a:p>
         </p:txBody>
       </p:sp>
@@ -13047,9 +13290,9 @@
               <a:buNone/>
             </a:pPr>
             <a:r>
-              <a:rPr lang="en-US" sz="1500" dirty="0">
-                <a:solidFill>
-                  <a:srgbClr val="A9A3C4"/>
+              <a:rPr lang="en-US" sz="2400" b="1" dirty="0">
+                <a:solidFill>
+                  <a:schemeClr val="bg1"/>
                 </a:solidFill>
                 <a:latin typeface="Calibri" pitchFamily="34" charset="0"/>
                 <a:ea typeface="Calibri" pitchFamily="34" charset="-122"/>
@@ -13057,7 +13300,11 @@
               </a:rPr>
               <a:t>Работает только для числа 20</a:t>
             </a:r>
-            <a:endParaRPr lang="en-US" sz="1500" dirty="0"/>
+            <a:endParaRPr lang="en-US" sz="2400" b="1" dirty="0">
+              <a:solidFill>
+                <a:schemeClr val="bg1"/>
+              </a:solidFill>
+            </a:endParaRPr>
           </a:p>
         </p:txBody>
       </p:sp>
@@ -13152,9 +13399,9 @@
               <a:buNone/>
             </a:pPr>
             <a:r>
-              <a:rPr lang="en-US" sz="1500" dirty="0">
-                <a:solidFill>
-                  <a:srgbClr val="A9A3C4"/>
+              <a:rPr lang="en-US" sz="2000" b="1" dirty="0">
+                <a:solidFill>
+                  <a:schemeClr val="bg1"/>
                 </a:solidFill>
                 <a:latin typeface="Calibri" pitchFamily="34" charset="0"/>
                 <a:ea typeface="Calibri" pitchFamily="34" charset="-122"/>
@@ -13162,7 +13409,11 @@
               </a:rPr>
               <a:t>Когда остановиться?</a:t>
             </a:r>
-            <a:endParaRPr lang="en-US" sz="1500" dirty="0"/>
+            <a:endParaRPr lang="en-US" sz="2000" b="1" dirty="0">
+              <a:solidFill>
+                <a:schemeClr val="bg1"/>
+              </a:solidFill>
+            </a:endParaRPr>
           </a:p>
         </p:txBody>
       </p:sp>
@@ -13257,7 +13508,7 @@
               <a:buNone/>
             </a:pPr>
             <a:r>
-              <a:rPr lang="en-US" sz="1500" dirty="0">
+              <a:rPr lang="en-US" sz="2400" b="1" dirty="0">
                 <a:solidFill>
                   <a:srgbClr val="3DD6A0"/>
                 </a:solidFill>
@@ -13267,7 +13518,7 @@
               </a:rPr>
               <a:t>Понятно и работает для любого числа</a:t>
             </a:r>
-            <a:endParaRPr lang="en-US" sz="1500" dirty="0"/>
+            <a:endParaRPr lang="en-US" sz="2400" b="1" dirty="0"/>
           </a:p>
         </p:txBody>
       </p:sp>
@@ -13407,9 +13658,9 @@
               <a:buNone/>
             </a:pPr>
             <a:r>
-              <a:rPr lang="en-US" sz="1600" i="1" dirty="0">
-                <a:solidFill>
-                  <a:srgbClr val="A9A3C4"/>
+              <a:rPr lang="en-US" sz="2000" b="1" i="1" dirty="0">
+                <a:solidFill>
+                  <a:schemeClr val="bg1"/>
                 </a:solidFill>
                 <a:latin typeface="Calibri" pitchFamily="34" charset="0"/>
                 <a:ea typeface="Calibri" pitchFamily="34" charset="-122"/>
@@ -13417,7 +13668,11 @@
               </a:rPr>
               <a:t>Самое трудное место сегодняшнего занятия</a:t>
             </a:r>
-            <a:endParaRPr lang="en-US" sz="1600" dirty="0"/>
+            <a:endParaRPr lang="en-US" sz="2000" b="1" dirty="0">
+              <a:solidFill>
+                <a:schemeClr val="bg1"/>
+              </a:solidFill>
+            </a:endParaRPr>
           </a:p>
         </p:txBody>
       </p:sp>
@@ -13475,7 +13730,7 @@
             <a:r>
               <a:rPr lang="en-US" sz="2000" b="1" dirty="0">
                 <a:solidFill>
-                  <a:srgbClr val="F2789F"/>
+                  <a:schemeClr val="bg1"/>
                 </a:solidFill>
                 <a:latin typeface="Calibri" pitchFamily="34" charset="0"/>
                 <a:ea typeface="Calibri" pitchFamily="34" charset="-122"/>
@@ -13483,7 +13738,11 @@
               </a:rPr>
               <a:t>«Раздели 20 на 4»</a:t>
             </a:r>
-            <a:endParaRPr lang="en-US" sz="2000" dirty="0"/>
+            <a:endParaRPr lang="en-US" sz="2000" dirty="0">
+              <a:solidFill>
+                <a:schemeClr val="bg1"/>
+              </a:solidFill>
+            </a:endParaRPr>
           </a:p>
         </p:txBody>
       </p:sp>
@@ -13512,7 +13771,7 @@
               <a:buNone/>
             </a:pPr>
             <a:r>
-              <a:rPr lang="en-US" sz="1600" dirty="0">
+              <a:rPr lang="en-US" sz="2000" b="1" dirty="0">
                 <a:solidFill>
                   <a:srgbClr val="FFFFFF"/>
                 </a:solidFill>
@@ -13522,14 +13781,14 @@
               </a:rPr>
               <a:t>Дал вам число 20 — работает.</a:t>
             </a:r>
-            <a:endParaRPr lang="en-US" sz="1600" dirty="0"/>
-          </a:p>
-          <a:p>
-            <a:pPr marL="0" indent="0">
-              <a:buNone/>
-            </a:pPr>
-            <a:r>
-              <a:rPr lang="en-US" sz="1600" dirty="0">
+            <a:endParaRPr lang="en-US" sz="2000" b="1" dirty="0"/>
+          </a:p>
+          <a:p>
+            <a:pPr marL="0" indent="0">
+              <a:buNone/>
+            </a:pPr>
+            <a:r>
+              <a:rPr lang="en-US" sz="2000" b="1" dirty="0">
                 <a:solidFill>
                   <a:srgbClr val="FFFFFF"/>
                 </a:solidFill>
@@ -13539,7 +13798,7 @@
               </a:rPr>
               <a:t>Дал 30 — инструкция сломалась: в ней написано именно 20.</a:t>
             </a:r>
-            <a:endParaRPr lang="en-US" sz="1600" dirty="0"/>
+            <a:endParaRPr lang="en-US" sz="2000" b="1" dirty="0"/>
           </a:p>
         </p:txBody>
       </p:sp>
@@ -13597,7 +13856,7 @@
             <a:r>
               <a:rPr lang="en-US" sz="2000" b="1" dirty="0">
                 <a:solidFill>
-                  <a:srgbClr val="3DD6A0"/>
+                  <a:schemeClr val="bg1"/>
                 </a:solidFill>
                 <a:latin typeface="Calibri" pitchFamily="34" charset="0"/>
                 <a:ea typeface="Calibri" pitchFamily="34" charset="-122"/>
@@ -13605,7 +13864,11 @@
               </a:rPr>
               <a:t>«Умножь введённое число на 2»</a:t>
             </a:r>
-            <a:endParaRPr lang="en-US" sz="2000" dirty="0"/>
+            <a:endParaRPr lang="en-US" sz="2000" dirty="0">
+              <a:solidFill>
+                <a:schemeClr val="bg1"/>
+              </a:solidFill>
+            </a:endParaRPr>
           </a:p>
         </p:txBody>
       </p:sp>
@@ -13634,7 +13897,7 @@
               <a:buNone/>
             </a:pPr>
             <a:r>
-              <a:rPr lang="en-US" sz="1600" dirty="0">
+              <a:rPr lang="en-US" sz="2000" b="1" dirty="0">
                 <a:solidFill>
                   <a:srgbClr val="FFFFFF"/>
                 </a:solidFill>
@@ -13644,14 +13907,14 @@
               </a:rPr>
               <a:t>Дал 20 — работает.</a:t>
             </a:r>
-            <a:endParaRPr lang="en-US" sz="1600" dirty="0"/>
-          </a:p>
-          <a:p>
-            <a:pPr marL="0" indent="0">
-              <a:buNone/>
-            </a:pPr>
-            <a:r>
-              <a:rPr lang="en-US" sz="1600" dirty="0">
+            <a:endParaRPr lang="en-US" sz="2000" b="1" dirty="0"/>
+          </a:p>
+          <a:p>
+            <a:pPr marL="0" indent="0">
+              <a:buNone/>
+            </a:pPr>
+            <a:r>
+              <a:rPr lang="en-US" sz="2000" b="1" dirty="0">
                 <a:solidFill>
                   <a:srgbClr val="FFFFFF"/>
                 </a:solidFill>
@@ -13661,14 +13924,14 @@
               </a:rPr>
               <a:t>Дал 30 — тоже работает.</a:t>
             </a:r>
-            <a:endParaRPr lang="en-US" sz="1600" dirty="0"/>
-          </a:p>
-          <a:p>
-            <a:pPr marL="0" indent="0">
-              <a:buNone/>
-            </a:pPr>
-            <a:r>
-              <a:rPr lang="en-US" sz="1600" dirty="0">
+            <a:endParaRPr lang="en-US" sz="2000" b="1" dirty="0"/>
+          </a:p>
+          <a:p>
+            <a:pPr marL="0" indent="0">
+              <a:buNone/>
+            </a:pPr>
+            <a:r>
+              <a:rPr lang="en-US" sz="2000" b="1" dirty="0">
                 <a:solidFill>
                   <a:srgbClr val="FFFFFF"/>
                 </a:solidFill>
@@ -13678,7 +13941,7 @@
               </a:rPr>
               <a:t>Дал любое число — работает.</a:t>
             </a:r>
-            <a:endParaRPr lang="en-US" sz="1600" dirty="0"/>
+            <a:endParaRPr lang="en-US" sz="2000" b="1" dirty="0"/>
           </a:p>
         </p:txBody>
       </p:sp>
@@ -13734,9 +13997,9 @@
               <a:buNone/>
             </a:pPr>
             <a:r>
-              <a:rPr lang="en-US" sz="1900" b="1" dirty="0">
-                <a:solidFill>
-                  <a:srgbClr val="4FD1E0"/>
+              <a:rPr lang="en-US" sz="2400" b="1" dirty="0">
+                <a:solidFill>
+                  <a:schemeClr val="bg1"/>
                 </a:solidFill>
                 <a:latin typeface="Calibri" pitchFamily="34" charset="0"/>
                 <a:ea typeface="Calibri" pitchFamily="34" charset="-122"/>
@@ -13744,7 +14007,11 @@
               </a:rPr>
               <a:t>Это и есть массовость</a:t>
             </a:r>
-            <a:endParaRPr lang="en-US" sz="1900" dirty="0"/>
+            <a:endParaRPr lang="en-US" sz="2400" dirty="0">
+              <a:solidFill>
+                <a:schemeClr val="bg1"/>
+              </a:solidFill>
+            </a:endParaRPr>
           </a:p>
         </p:txBody>
       </p:sp>
@@ -13773,9 +14040,9 @@
               <a:buNone/>
             </a:pPr>
             <a:r>
-              <a:rPr lang="en-US" sz="1600" dirty="0">
-                <a:solidFill>
-                  <a:srgbClr val="FFFFFF"/>
+              <a:rPr lang="en-US" sz="2400" dirty="0">
+                <a:solidFill>
+                  <a:schemeClr val="bg1"/>
                 </a:solidFill>
                 <a:latin typeface="Calibri" pitchFamily="34" charset="0"/>
                 <a:ea typeface="Calibri" pitchFamily="34" charset="-122"/>
@@ -13783,7 +14050,11 @@
               </a:rPr>
               <a:t>Алгоритм должен работать для всех похожих задач, а не для одного конкретного случая. Иначе это не алгоритм, а разовое указание.</a:t>
             </a:r>
-            <a:endParaRPr lang="en-US" sz="1600" dirty="0"/>
+            <a:endParaRPr lang="en-US" sz="2400" dirty="0">
+              <a:solidFill>
+                <a:schemeClr val="bg1"/>
+              </a:solidFill>
+            </a:endParaRPr>
           </a:p>
         </p:txBody>
       </p:sp>
@@ -14077,7 +14348,7 @@
               <a:buNone/>
             </a:pPr>
             <a:r>
-              <a:rPr lang="en-US" sz="1800" dirty="0">
+              <a:rPr lang="en-US" sz="2400" b="1" dirty="0">
                 <a:solidFill>
                   <a:srgbClr val="FFFFFF"/>
                 </a:solidFill>
@@ -14087,7 +14358,7 @@
               </a:rPr>
               <a:t>Запишите пример в тетрадь</a:t>
             </a:r>
-            <a:endParaRPr lang="en-US" sz="1800" dirty="0"/>
+            <a:endParaRPr lang="en-US" sz="2400" b="1" dirty="0"/>
           </a:p>
         </p:txBody>
       </p:sp>
@@ -14143,7 +14414,7 @@
               <a:buNone/>
             </a:pPr>
             <a:r>
-              <a:rPr lang="en-US" sz="1800" dirty="0">
+              <a:rPr lang="en-US" sz="2400" b="1" dirty="0">
                 <a:solidFill>
                   <a:srgbClr val="FFFFFF"/>
                 </a:solidFill>
@@ -14153,7 +14424,7 @@
               </a:rPr>
               <a:t>Рядом напишите, почему это не алгоритм</a:t>
             </a:r>
-            <a:endParaRPr lang="en-US" sz="1800" dirty="0"/>
+            <a:endParaRPr lang="en-US" sz="2400" b="1" dirty="0"/>
           </a:p>
         </p:txBody>
       </p:sp>
@@ -14418,7 +14689,7 @@
               <a:buNone/>
             </a:pPr>
             <a:r>
-              <a:rPr lang="en-US" sz="1700" b="1" dirty="0">
+              <a:rPr lang="en-US" sz="2400" b="1" dirty="0">
                 <a:solidFill>
                   <a:srgbClr val="FFFFFF"/>
                 </a:solidFill>
@@ -14428,7 +14699,7 @@
               </a:rPr>
               <a:t>Дискретность</a:t>
             </a:r>
-            <a:endParaRPr lang="en-US" sz="1700" dirty="0"/>
+            <a:endParaRPr lang="en-US" sz="2400" dirty="0"/>
           </a:p>
         </p:txBody>
       </p:sp>
@@ -14457,9 +14728,9 @@
               <a:buNone/>
             </a:pPr>
             <a:r>
-              <a:rPr lang="en-US" sz="1300" dirty="0">
-                <a:solidFill>
-                  <a:srgbClr val="A9A3C4"/>
+              <a:rPr lang="en-US" sz="2400" b="1" dirty="0">
+                <a:solidFill>
+                  <a:schemeClr val="bg1"/>
                 </a:solidFill>
                 <a:latin typeface="Calibri" pitchFamily="34" charset="0"/>
                 <a:ea typeface="Calibri" pitchFamily="34" charset="-122"/>
@@ -14467,7 +14738,11 @@
               </a:rPr>
               <a:t>Разбит на отдельные шаги</a:t>
             </a:r>
-            <a:endParaRPr lang="en-US" sz="1300" dirty="0"/>
+            <a:endParaRPr lang="en-US" sz="2400" b="1" dirty="0">
+              <a:solidFill>
+                <a:schemeClr val="bg1"/>
+              </a:solidFill>
+            </a:endParaRPr>
           </a:p>
         </p:txBody>
       </p:sp>
@@ -14621,7 +14896,7 @@
               <a:buNone/>
             </a:pPr>
             <a:r>
-              <a:rPr lang="en-US" sz="1700" b="1" dirty="0">
+              <a:rPr lang="en-US" sz="2200" b="1" dirty="0">
                 <a:solidFill>
                   <a:srgbClr val="FFFFFF"/>
                 </a:solidFill>
@@ -14631,7 +14906,7 @@
               </a:rPr>
               <a:t>Определённость</a:t>
             </a:r>
-            <a:endParaRPr lang="en-US" sz="1700" dirty="0"/>
+            <a:endParaRPr lang="en-US" sz="2200" dirty="0"/>
           </a:p>
         </p:txBody>
       </p:sp>
@@ -14660,7 +14935,7 @@
               <a:buNone/>
             </a:pPr>
             <a:r>
-              <a:rPr lang="en-US" sz="1300" dirty="0">
+              <a:rPr lang="en-US" sz="2000" b="1" dirty="0">
                 <a:solidFill>
                   <a:srgbClr val="A9A3C4"/>
                 </a:solidFill>
@@ -14670,7 +14945,7 @@
               </a:rPr>
               <a:t>Каждый шаг понятен однозначно</a:t>
             </a:r>
-            <a:endParaRPr lang="en-US" sz="1300" dirty="0"/>
+            <a:endParaRPr lang="en-US" sz="2000" b="1" dirty="0"/>
           </a:p>
         </p:txBody>
       </p:sp>
@@ -14824,7 +15099,7 @@
               <a:buNone/>
             </a:pPr>
             <a:r>
-              <a:rPr lang="en-US" sz="1700" b="1" dirty="0">
+              <a:rPr lang="en-US" sz="2400" b="1" dirty="0">
                 <a:solidFill>
                   <a:srgbClr val="FFFFFF"/>
                 </a:solidFill>
@@ -14834,7 +15109,7 @@
               </a:rPr>
               <a:t>Конечность</a:t>
             </a:r>
-            <a:endParaRPr lang="en-US" sz="1700" dirty="0"/>
+            <a:endParaRPr lang="en-US" sz="2400" dirty="0"/>
           </a:p>
         </p:txBody>
       </p:sp>
@@ -14863,9 +15138,9 @@
               <a:buNone/>
             </a:pPr>
             <a:r>
-              <a:rPr lang="en-US" sz="1300" dirty="0">
-                <a:solidFill>
-                  <a:srgbClr val="A9A3C4"/>
+              <a:rPr lang="en-US" sz="2000" b="1" dirty="0">
+                <a:solidFill>
+                  <a:schemeClr val="bg1"/>
                 </a:solidFill>
                 <a:latin typeface="Calibri" pitchFamily="34" charset="0"/>
                 <a:ea typeface="Calibri" pitchFamily="34" charset="-122"/>
@@ -14873,7 +15148,11 @@
               </a:rPr>
               <a:t>Заканчивается за конечное число шагов</a:t>
             </a:r>
-            <a:endParaRPr lang="en-US" sz="1300" dirty="0"/>
+            <a:endParaRPr lang="en-US" sz="2000" b="1" dirty="0">
+              <a:solidFill>
+                <a:schemeClr val="bg1"/>
+              </a:solidFill>
+            </a:endParaRPr>
           </a:p>
         </p:txBody>
       </p:sp>
@@ -15027,9 +15306,9 @@
               <a:buNone/>
             </a:pPr>
             <a:r>
-              <a:rPr lang="en-US" sz="1700" b="1" dirty="0">
-                <a:solidFill>
-                  <a:srgbClr val="FFFFFF"/>
+              <a:rPr lang="en-US" sz="2000" b="1" dirty="0">
+                <a:solidFill>
+                  <a:schemeClr val="bg1"/>
                 </a:solidFill>
                 <a:latin typeface="Calibri" pitchFamily="34" charset="0"/>
                 <a:ea typeface="Calibri" pitchFamily="34" charset="-122"/>
@@ -15037,7 +15316,11 @@
               </a:rPr>
               <a:t>Результативность</a:t>
             </a:r>
-            <a:endParaRPr lang="en-US" sz="1700" dirty="0"/>
+            <a:endParaRPr lang="en-US" sz="2000" dirty="0">
+              <a:solidFill>
+                <a:schemeClr val="bg1"/>
+              </a:solidFill>
+            </a:endParaRPr>
           </a:p>
         </p:txBody>
       </p:sp>
@@ -15066,9 +15349,9 @@
               <a:buNone/>
             </a:pPr>
             <a:r>
-              <a:rPr lang="en-US" sz="1300" dirty="0">
-                <a:solidFill>
-                  <a:srgbClr val="A9A3C4"/>
+              <a:rPr lang="en-US" sz="2000" b="1" dirty="0">
+                <a:solidFill>
+                  <a:schemeClr val="bg1"/>
                 </a:solidFill>
                 <a:latin typeface="Calibri" pitchFamily="34" charset="0"/>
                 <a:ea typeface="Calibri" pitchFamily="34" charset="-122"/>
@@ -15076,7 +15359,11 @@
               </a:rPr>
               <a:t>Даёт определённый результат</a:t>
             </a:r>
-            <a:endParaRPr lang="en-US" sz="1300" dirty="0"/>
+            <a:endParaRPr lang="en-US" sz="2000" b="1" dirty="0">
+              <a:solidFill>
+                <a:schemeClr val="bg1"/>
+              </a:solidFill>
+            </a:endParaRPr>
           </a:p>
         </p:txBody>
       </p:sp>
@@ -15230,7 +15517,7 @@
               <a:buNone/>
             </a:pPr>
             <a:r>
-              <a:rPr lang="en-US" sz="1700" b="1" dirty="0">
+              <a:rPr lang="en-US" sz="2400" b="1" dirty="0">
                 <a:solidFill>
                   <a:srgbClr val="FFFFFF"/>
                 </a:solidFill>
@@ -15240,7 +15527,7 @@
               </a:rPr>
               <a:t>Массовость</a:t>
             </a:r>
-            <a:endParaRPr lang="en-US" sz="1700" dirty="0"/>
+            <a:endParaRPr lang="en-US" sz="2400" dirty="0"/>
           </a:p>
         </p:txBody>
       </p:sp>
@@ -15269,9 +15556,9 @@
               <a:buNone/>
             </a:pPr>
             <a:r>
-              <a:rPr lang="en-US" sz="1300" dirty="0">
-                <a:solidFill>
-                  <a:srgbClr val="A9A3C4"/>
+              <a:rPr lang="en-US" sz="2000" b="1" dirty="0">
+                <a:solidFill>
+                  <a:schemeClr val="bg1"/>
                 </a:solidFill>
                 <a:latin typeface="Calibri" pitchFamily="34" charset="0"/>
                 <a:ea typeface="Calibri" pitchFamily="34" charset="-122"/>
@@ -15279,7 +15566,11 @@
               </a:rPr>
               <a:t>Работает для класса похожих задач</a:t>
             </a:r>
-            <a:endParaRPr lang="en-US" sz="1300" dirty="0"/>
+            <a:endParaRPr lang="en-US" sz="2000" b="1" dirty="0">
+              <a:solidFill>
+                <a:schemeClr val="bg1"/>
+              </a:solidFill>
+            </a:endParaRPr>
           </a:p>
         </p:txBody>
       </p:sp>
@@ -15415,8 +15706,8 @@
         </p:nvSpPr>
         <p:spPr>
           <a:xfrm>
-            <a:off x="640080" y="1783080"/>
-            <a:ext cx="10881360" cy="786384"/>
+            <a:off x="412376" y="1783080"/>
+            <a:ext cx="11322424" cy="786384"/>
           </a:xfrm>
           <a:prstGeom prst="roundRect">
             <a:avLst>
@@ -15474,7 +15765,7 @@
         </p:nvSpPr>
         <p:spPr>
           <a:xfrm>
-            <a:off x="868680" y="1956816"/>
+            <a:off x="822960" y="1970532"/>
             <a:ext cx="438912" cy="438912"/>
           </a:xfrm>
           <a:prstGeom prst="rect">
@@ -15534,7 +15825,7 @@
           <a:p>
             <a:pPr latinLnBrk="1"/>
             <a:r>
-              <a:rPr lang="ru-RU" sz="1400" b="1" dirty="0">
+              <a:rPr lang="ru-RU" sz="2000" b="1" dirty="0">
                 <a:solidFill>
                   <a:schemeClr val="bg1"/>
                 </a:solidFill>
@@ -15575,7 +15866,7 @@
           <a:p>
             <a:pPr latinLnBrk="1"/>
             <a:r>
-              <a:rPr lang="ru-RU" sz="1600" dirty="0" err="1">
+              <a:rPr lang="ru-RU" sz="2000" dirty="0" err="1">
                 <a:solidFill>
                   <a:schemeClr val="bg1"/>
                 </a:solidFill>
@@ -15585,7 +15876,7 @@
               <a:t>XGBoost</a:t>
             </a:r>
             <a:r>
-              <a:rPr lang="ru-RU" sz="1600" dirty="0">
+              <a:rPr lang="ru-RU" sz="2000" dirty="0">
                 <a:solidFill>
                   <a:schemeClr val="bg1"/>
                 </a:solidFill>
@@ -15595,7 +15886,7 @@
               <a:t>, </a:t>
             </a:r>
             <a:r>
-              <a:rPr lang="ru-RU" sz="1600" dirty="0" err="1">
+              <a:rPr lang="ru-RU" sz="2000" dirty="0" err="1">
                 <a:solidFill>
                   <a:schemeClr val="bg1"/>
                 </a:solidFill>
@@ -15605,7 +15896,7 @@
               <a:t>LightGBM</a:t>
             </a:r>
             <a:r>
-              <a:rPr lang="ru-RU" sz="1600" dirty="0">
+              <a:rPr lang="ru-RU" sz="2000" dirty="0">
                 <a:solidFill>
                   <a:schemeClr val="bg1"/>
                 </a:solidFill>
@@ -15615,7 +15906,7 @@
               <a:t>, </a:t>
             </a:r>
             <a:r>
-              <a:rPr lang="ru-RU" sz="1600" dirty="0" err="1">
+              <a:rPr lang="ru-RU" sz="2000" dirty="0" err="1">
                 <a:solidFill>
                   <a:schemeClr val="bg1"/>
                 </a:solidFill>
@@ -15624,7 +15915,7 @@
               </a:rPr>
               <a:t>CatBoost</a:t>
             </a:r>
-            <a:endParaRPr lang="ru-RU" sz="1600" dirty="0">
+            <a:endParaRPr lang="ru-RU" sz="2000" dirty="0">
               <a:solidFill>
                 <a:schemeClr val="bg1"/>
               </a:solidFill>
@@ -15710,8 +16001,8 @@
         </p:nvSpPr>
         <p:spPr>
           <a:xfrm>
-            <a:off x="640080" y="2688336"/>
-            <a:ext cx="10881360" cy="786384"/>
+            <a:off x="412376" y="2688336"/>
+            <a:ext cx="11109064" cy="786384"/>
           </a:xfrm>
           <a:prstGeom prst="roundRect">
             <a:avLst>
@@ -15828,7 +16119,7 @@
           <a:lstStyle/>
           <a:p>
             <a:r>
-              <a:rPr lang="ru-RU" sz="1400" b="1" dirty="0">
+              <a:rPr lang="ru-RU" sz="2000" b="1" dirty="0">
                 <a:solidFill>
                   <a:schemeClr val="bg1"/>
                 </a:solidFill>
@@ -15842,7 +16133,7 @@
             <a:pPr marL="0" indent="0">
               <a:buNone/>
             </a:pPr>
-            <a:endParaRPr lang="en-US" sz="1700" dirty="0"/>
+            <a:endParaRPr lang="en-US" sz="2000" dirty="0"/>
           </a:p>
         </p:txBody>
       </p:sp>
@@ -15875,7 +16166,7 @@
           <a:p>
             <a:pPr latinLnBrk="1"/>
             <a:r>
-              <a:rPr lang="ru-RU" sz="1600" dirty="0">
+              <a:rPr lang="ru-RU" sz="2000" dirty="0">
                 <a:solidFill>
                   <a:schemeClr val="bg1"/>
                 </a:solidFill>
@@ -15885,7 +16176,7 @@
               <a:t>K-</a:t>
             </a:r>
             <a:r>
-              <a:rPr lang="ru-RU" sz="1600" dirty="0" err="1">
+              <a:rPr lang="ru-RU" sz="2000" dirty="0" err="1">
                 <a:solidFill>
                   <a:schemeClr val="bg1"/>
                 </a:solidFill>
@@ -15895,11 +16186,15 @@
               <a:t>Means</a:t>
             </a:r>
             <a:r>
-              <a:rPr lang="ru-RU" dirty="0"/>
+              <a:rPr lang="ru-RU" sz="2000" dirty="0">
+                <a:solidFill>
+                  <a:schemeClr val="bg1"/>
+                </a:solidFill>
+              </a:rPr>
               <a:t> + </a:t>
             </a:r>
             <a:r>
-              <a:rPr lang="ru-RU" sz="1600" dirty="0">
+              <a:rPr lang="ru-RU" sz="2000" dirty="0">
                 <a:solidFill>
                   <a:schemeClr val="bg1"/>
                 </a:solidFill>
@@ -15971,8 +16266,8 @@
         </p:nvSpPr>
         <p:spPr>
           <a:xfrm>
-            <a:off x="640080" y="3593592"/>
-            <a:ext cx="10881360" cy="786384"/>
+            <a:off x="412376" y="3593592"/>
+            <a:ext cx="11109064" cy="786384"/>
           </a:xfrm>
           <a:prstGeom prst="roundRect">
             <a:avLst>
@@ -16090,7 +16385,7 @@
           <a:p>
             <a:pPr latinLnBrk="1"/>
             <a:r>
-              <a:rPr lang="ru-RU" sz="1400" b="1" dirty="0">
+              <a:rPr lang="ru-RU" sz="2000" b="1" dirty="0">
                 <a:solidFill>
                   <a:schemeClr val="bg1"/>
                 </a:solidFill>
@@ -16131,7 +16426,7 @@
           <a:p>
             <a:pPr latinLnBrk="1"/>
             <a:r>
-              <a:rPr lang="ru-RU" sz="1600" dirty="0">
+              <a:rPr lang="ru-RU" sz="2000" dirty="0">
                 <a:solidFill>
                   <a:schemeClr val="bg1"/>
                 </a:solidFill>
@@ -16199,8 +16494,8 @@
         </p:nvSpPr>
         <p:spPr>
           <a:xfrm>
-            <a:off x="640080" y="4498848"/>
-            <a:ext cx="10881360" cy="786384"/>
+            <a:off x="412376" y="4498848"/>
+            <a:ext cx="11109064" cy="786384"/>
           </a:xfrm>
           <a:prstGeom prst="roundRect">
             <a:avLst>
@@ -16318,7 +16613,7 @@
           <a:p>
             <a:pPr latinLnBrk="1"/>
             <a:r>
-              <a:rPr lang="ru-RU" sz="1400" b="1" dirty="0">
+              <a:rPr lang="ru-RU" sz="2000" b="1" dirty="0">
                 <a:solidFill>
                   <a:schemeClr val="bg1"/>
                 </a:solidFill>
@@ -16359,7 +16654,7 @@
           <a:p>
             <a:pPr latinLnBrk="1"/>
             <a:r>
-              <a:rPr lang="ru-RU" sz="1400" b="1" dirty="0" err="1">
+              <a:rPr lang="ru-RU" sz="2000" b="1" dirty="0" err="1">
                 <a:solidFill>
                   <a:schemeClr val="bg1"/>
                 </a:solidFill>
@@ -16369,7 +16664,7 @@
               <a:t>Transformer</a:t>
             </a:r>
             <a:r>
-              <a:rPr lang="ru-RU" sz="1400" b="1" dirty="0">
+              <a:rPr lang="ru-RU" sz="2000" b="1" dirty="0">
                 <a:solidFill>
                   <a:schemeClr val="bg1"/>
                 </a:solidFill>

</xml_diff>